<commit_message>
Update README, presentation PPTX, and all project features on GitHub
</commit_message>
<xml_diff>
--- a/SecureLLM_Shield_Presentation.pptx
+++ b/SecureLLM_Shield_Presentation.pptx
@@ -1,30 +1,33 @@
 
 <file path=ppt/presentation.xml><?xml version="1.0" encoding="utf-8"?>
-<p:presentation xmlns:a="http://schemas.openxmlformats.org/drawingml/2006/main" xmlns:r="http://schemas.openxmlformats.org/officeDocument/2006/relationships" xmlns:p="http://schemas.openxmlformats.org/presentationml/2006/main" saveSubsetFonts="1" autoCompressPictures="0">
+<p:presentation xmlns:a="http://schemas.openxmlformats.org/drawingml/2006/main" xmlns:r="http://schemas.openxmlformats.org/officeDocument/2006/relationships" xmlns:p="http://schemas.openxmlformats.org/presentationml/2006/main" autoCompressPictures="0">
   <p:sldMasterIdLst>
     <p:sldMasterId id="2147483648" r:id="rId1"/>
   </p:sldMasterIdLst>
+  <p:notesMasterIdLst>
+    <p:notesMasterId r:id="rId4"/>
+  </p:notesMasterIdLst>
   <p:sldIdLst>
-    <p:sldId id="256" r:id="rId7"/>
-    <p:sldId id="257" r:id="rId9"/>
-    <p:sldId id="258" r:id="rId10"/>
-    <p:sldId id="259" r:id="rId11"/>
-    <p:sldId id="260" r:id="rId12"/>
-    <p:sldId id="261" r:id="rId13"/>
-    <p:sldId id="262" r:id="rId14"/>
-    <p:sldId id="263" r:id="rId15"/>
-    <p:sldId id="264" r:id="rId16"/>
-    <p:sldId id="265" r:id="rId17"/>
-    <p:sldId id="266" r:id="rId18"/>
-    <p:sldId id="267" r:id="rId19"/>
-    <p:sldId id="268" r:id="rId20"/>
-    <p:sldId id="269" r:id="rId21"/>
-    <p:sldId id="270" r:id="rId22"/>
-    <p:sldId id="271" r:id="rId23"/>
-    <p:sldId id="272" r:id="rId24"/>
-    <p:sldId id="273" r:id="rId25"/>
+    <p:sldId id="256" r:id="rId3"/>
+    <p:sldId id="257" r:id="rId5"/>
+    <p:sldId id="258" r:id="rId6"/>
+    <p:sldId id="259" r:id="rId7"/>
+    <p:sldId id="260" r:id="rId8"/>
+    <p:sldId id="261" r:id="rId9"/>
+    <p:sldId id="262" r:id="rId10"/>
+    <p:sldId id="263" r:id="rId11"/>
+    <p:sldId id="264" r:id="rId12"/>
+    <p:sldId id="265" r:id="rId13"/>
+    <p:sldId id="266" r:id="rId14"/>
+    <p:sldId id="267" r:id="rId15"/>
+    <p:sldId id="268" r:id="rId16"/>
+    <p:sldId id="269" r:id="rId17"/>
+    <p:sldId id="270" r:id="rId18"/>
+    <p:sldId id="271" r:id="rId19"/>
+    <p:sldId id="272" r:id="rId20"/>
+    <p:sldId id="273" r:id="rId21"/>
   </p:sldIdLst>
-  <p:sldSz cx="12191695" cy="6858000" type="screen4x3"/>
+  <p:sldSz cx="12191365" cy="6858000" type="screen4x3"/>
   <p:notesSz cx="6858000" cy="9144000"/>
   <p:defaultTextStyle>
     <a:defPPr>
@@ -121,11 +124,27 @@
       </a:defRPr>
     </a:lvl9pPr>
   </p:defaultTextStyle>
+  <p:extLst>
+    <p:ext uri="{EFAFB233-063F-42B5-8137-9DF3F51BA10A}">
+      <p15:sldGuideLst xmlns:p15="http://schemas.microsoft.com/office/powerpoint/2012/main">
+        <p15:guide id="1" orient="horz" pos="2160" userDrawn="1">
+          <p15:clr>
+            <a:srgbClr val="A4A3A4"/>
+          </p15:clr>
+        </p15:guide>
+        <p15:guide id="2" pos="2880" userDrawn="1">
+          <p15:clr>
+            <a:srgbClr val="A4A3A4"/>
+          </p15:clr>
+        </p15:guide>
+      </p15:sldGuideLst>
+    </p:ext>
+  </p:extLst>
 </p:presentation>
 </file>
 
 <file path=ppt/notesMasters/notesMaster1.xml><?xml version="1.0" encoding="utf-8"?>
-<p:notesMaster xmlns:a="http://schemas.openxmlformats.org/drawingml/2006/main" xmlns:p="http://schemas.openxmlformats.org/presentationml/2006/main" xmlns:r="http://schemas.openxmlformats.org/officeDocument/2006/relationships">
+<p:notesMaster xmlns:a="http://schemas.openxmlformats.org/drawingml/2006/main" xmlns:r="http://schemas.openxmlformats.org/officeDocument/2006/relationships" xmlns:p="http://schemas.openxmlformats.org/presentationml/2006/main">
   <p:cSld>
     <p:bg>
       <p:bgRef idx="1001">
@@ -206,7 +225,6 @@
           <a:p>
             <a:fld id="{0F89C1C7-3DCD-1040-A9CF-14679D8B5DDD}" type="datetimeFigureOut">
               <a:rPr lang="en-US" smtClean="0"/>
-              <a:t>10/17/16</a:t>
             </a:fld>
             <a:endParaRPr lang="en-US"/>
           </a:p>
@@ -273,6 +291,7 @@
               <a:rPr lang="en-US" smtClean="0"/>
               <a:t>Click to edit Master text styles</a:t>
             </a:r>
+            <a:endParaRPr lang="en-US" smtClean="0"/>
           </a:p>
           <a:p>
             <a:pPr lvl="1"/>
@@ -280,6 +299,7 @@
               <a:rPr lang="en-US" smtClean="0"/>
               <a:t>Second level</a:t>
             </a:r>
+            <a:endParaRPr lang="en-US" smtClean="0"/>
           </a:p>
           <a:p>
             <a:pPr lvl="2"/>
@@ -287,6 +307,7 @@
               <a:rPr lang="en-US" smtClean="0"/>
               <a:t>Third level</a:t>
             </a:r>
+            <a:endParaRPr lang="en-US" smtClean="0"/>
           </a:p>
           <a:p>
             <a:pPr lvl="3"/>
@@ -294,6 +315,7 @@
               <a:rPr lang="en-US" smtClean="0"/>
               <a:t>Fourth level</a:t>
             </a:r>
+            <a:endParaRPr lang="en-US" smtClean="0"/>
           </a:p>
           <a:p>
             <a:pPr lvl="4"/>
@@ -365,18 +387,12 @@
           <a:p>
             <a:fld id="{BB5E49A5-4136-284D-997B-48E1D791AD67}" type="slidenum">
               <a:rPr lang="en-US" smtClean="0"/>
-              <a:t>‹#›</a:t>
             </a:fld>
             <a:endParaRPr lang="en-US"/>
           </a:p>
         </p:txBody>
       </p:sp>
     </p:spTree>
-    <p:extLst>
-      <p:ext uri="{BB962C8B-B14F-4D97-AF65-F5344CB8AC3E}">
-        <p14:creationId xmlns:p14="http://schemas.microsoft.com/office/powerpoint/2010/main" val="2623252185"/>
-      </p:ext>
-    </p:extLst>
   </p:cSld>
   <p:clrMap bg1="lt1" tx1="dk1" bg2="lt2" tx2="dk2" accent1="accent1" accent2="accent2" accent3="accent3" accent4="accent4" accent5="accent5" accent6="accent6" hlink="hlink" folHlink="folHlink"/>
   <p:notesStyle>
@@ -475,7 +491,7 @@
 </file>
 
 <file path=ppt/notesSlides/notesSlide1.xml><?xml version="1.0" encoding="utf-8"?>
-<p:notes xmlns:a="http://schemas.openxmlformats.org/drawingml/2006/main" xmlns:p="http://schemas.openxmlformats.org/presentationml/2006/main" xmlns:r="http://schemas.openxmlformats.org/officeDocument/2006/relationships">
+<p:notes xmlns:a="http://schemas.openxmlformats.org/drawingml/2006/main" xmlns:r="http://schemas.openxmlformats.org/officeDocument/2006/relationships" xmlns:p="http://schemas.openxmlformats.org/presentationml/2006/main">
   <p:cSld>
     <p:spTree>
       <p:nvGrpSpPr>
@@ -510,7 +526,7 @@
             <a:spLocks noGrp="1"/>
           </p:cNvSpPr>
           <p:nvPr>
-            <p:ph type="body" idx="3" sz="quarter"/>
+            <p:ph type="body" sz="quarter" idx="3"/>
           </p:nvPr>
         </p:nvSpPr>
         <p:spPr/>
@@ -531,7 +547,7 @@
             <a:spLocks noGrp="1"/>
           </p:cNvSpPr>
           <p:nvPr>
-            <p:ph type="sldNum" idx="5" sz="quarter"/>
+            <p:ph type="sldNum" sz="quarter" idx="5"/>
           </p:nvPr>
         </p:nvSpPr>
         <p:spPr/>
@@ -545,7 +561,7 @@
 </file>
 
 <file path=ppt/notesSlides/notesSlide10.xml><?xml version="1.0" encoding="utf-8"?>
-<p:notes xmlns:a="http://schemas.openxmlformats.org/drawingml/2006/main" xmlns:p="http://schemas.openxmlformats.org/presentationml/2006/main" xmlns:r="http://schemas.openxmlformats.org/officeDocument/2006/relationships">
+<p:notes xmlns:a="http://schemas.openxmlformats.org/drawingml/2006/main" xmlns:r="http://schemas.openxmlformats.org/officeDocument/2006/relationships" xmlns:p="http://schemas.openxmlformats.org/presentationml/2006/main">
   <p:cSld>
     <p:spTree>
       <p:nvGrpSpPr>
@@ -580,7 +596,7 @@
             <a:spLocks noGrp="1"/>
           </p:cNvSpPr>
           <p:nvPr>
-            <p:ph type="body" idx="3" sz="quarter"/>
+            <p:ph type="body" sz="quarter" idx="3"/>
           </p:nvPr>
         </p:nvSpPr>
         <p:spPr/>
@@ -601,7 +617,7 @@
             <a:spLocks noGrp="1"/>
           </p:cNvSpPr>
           <p:nvPr>
-            <p:ph type="sldNum" idx="5" sz="quarter"/>
+            <p:ph type="sldNum" sz="quarter" idx="5"/>
           </p:nvPr>
         </p:nvSpPr>
         <p:spPr/>
@@ -615,7 +631,7 @@
 </file>
 
 <file path=ppt/notesSlides/notesSlide11.xml><?xml version="1.0" encoding="utf-8"?>
-<p:notes xmlns:a="http://schemas.openxmlformats.org/drawingml/2006/main" xmlns:p="http://schemas.openxmlformats.org/presentationml/2006/main" xmlns:r="http://schemas.openxmlformats.org/officeDocument/2006/relationships">
+<p:notes xmlns:a="http://schemas.openxmlformats.org/drawingml/2006/main" xmlns:r="http://schemas.openxmlformats.org/officeDocument/2006/relationships" xmlns:p="http://schemas.openxmlformats.org/presentationml/2006/main">
   <p:cSld>
     <p:spTree>
       <p:nvGrpSpPr>
@@ -650,7 +666,7 @@
             <a:spLocks noGrp="1"/>
           </p:cNvSpPr>
           <p:nvPr>
-            <p:ph type="body" idx="3" sz="quarter"/>
+            <p:ph type="body" sz="quarter" idx="3"/>
           </p:nvPr>
         </p:nvSpPr>
         <p:spPr/>
@@ -671,7 +687,7 @@
             <a:spLocks noGrp="1"/>
           </p:cNvSpPr>
           <p:nvPr>
-            <p:ph type="sldNum" idx="5" sz="quarter"/>
+            <p:ph type="sldNum" sz="quarter" idx="5"/>
           </p:nvPr>
         </p:nvSpPr>
         <p:spPr/>
@@ -685,7 +701,7 @@
 </file>
 
 <file path=ppt/notesSlides/notesSlide12.xml><?xml version="1.0" encoding="utf-8"?>
-<p:notes xmlns:a="http://schemas.openxmlformats.org/drawingml/2006/main" xmlns:p="http://schemas.openxmlformats.org/presentationml/2006/main" xmlns:r="http://schemas.openxmlformats.org/officeDocument/2006/relationships">
+<p:notes xmlns:a="http://schemas.openxmlformats.org/drawingml/2006/main" xmlns:r="http://schemas.openxmlformats.org/officeDocument/2006/relationships" xmlns:p="http://schemas.openxmlformats.org/presentationml/2006/main">
   <p:cSld>
     <p:spTree>
       <p:nvGrpSpPr>
@@ -720,7 +736,7 @@
             <a:spLocks noGrp="1"/>
           </p:cNvSpPr>
           <p:nvPr>
-            <p:ph type="body" idx="3" sz="quarter"/>
+            <p:ph type="body" sz="quarter" idx="3"/>
           </p:nvPr>
         </p:nvSpPr>
         <p:spPr/>
@@ -741,7 +757,7 @@
             <a:spLocks noGrp="1"/>
           </p:cNvSpPr>
           <p:nvPr>
-            <p:ph type="sldNum" idx="5" sz="quarter"/>
+            <p:ph type="sldNum" sz="quarter" idx="5"/>
           </p:nvPr>
         </p:nvSpPr>
         <p:spPr/>
@@ -755,7 +771,7 @@
 </file>
 
 <file path=ppt/notesSlides/notesSlide13.xml><?xml version="1.0" encoding="utf-8"?>
-<p:notes xmlns:a="http://schemas.openxmlformats.org/drawingml/2006/main" xmlns:p="http://schemas.openxmlformats.org/presentationml/2006/main" xmlns:r="http://schemas.openxmlformats.org/officeDocument/2006/relationships">
+<p:notes xmlns:a="http://schemas.openxmlformats.org/drawingml/2006/main" xmlns:r="http://schemas.openxmlformats.org/officeDocument/2006/relationships" xmlns:p="http://schemas.openxmlformats.org/presentationml/2006/main">
   <p:cSld>
     <p:spTree>
       <p:nvGrpSpPr>
@@ -790,7 +806,7 @@
             <a:spLocks noGrp="1"/>
           </p:cNvSpPr>
           <p:nvPr>
-            <p:ph type="body" idx="3" sz="quarter"/>
+            <p:ph type="body" sz="quarter" idx="3"/>
           </p:nvPr>
         </p:nvSpPr>
         <p:spPr/>
@@ -811,7 +827,7 @@
             <a:spLocks noGrp="1"/>
           </p:cNvSpPr>
           <p:nvPr>
-            <p:ph type="sldNum" idx="5" sz="quarter"/>
+            <p:ph type="sldNum" sz="quarter" idx="5"/>
           </p:nvPr>
         </p:nvSpPr>
         <p:spPr/>
@@ -825,7 +841,7 @@
 </file>
 
 <file path=ppt/notesSlides/notesSlide14.xml><?xml version="1.0" encoding="utf-8"?>
-<p:notes xmlns:a="http://schemas.openxmlformats.org/drawingml/2006/main" xmlns:p="http://schemas.openxmlformats.org/presentationml/2006/main" xmlns:r="http://schemas.openxmlformats.org/officeDocument/2006/relationships">
+<p:notes xmlns:a="http://schemas.openxmlformats.org/drawingml/2006/main" xmlns:r="http://schemas.openxmlformats.org/officeDocument/2006/relationships" xmlns:p="http://schemas.openxmlformats.org/presentationml/2006/main">
   <p:cSld>
     <p:spTree>
       <p:nvGrpSpPr>
@@ -860,7 +876,7 @@
             <a:spLocks noGrp="1"/>
           </p:cNvSpPr>
           <p:nvPr>
-            <p:ph type="body" idx="3" sz="quarter"/>
+            <p:ph type="body" sz="quarter" idx="3"/>
           </p:nvPr>
         </p:nvSpPr>
         <p:spPr/>
@@ -881,7 +897,7 @@
             <a:spLocks noGrp="1"/>
           </p:cNvSpPr>
           <p:nvPr>
-            <p:ph type="sldNum" idx="5" sz="quarter"/>
+            <p:ph type="sldNum" sz="quarter" idx="5"/>
           </p:nvPr>
         </p:nvSpPr>
         <p:spPr/>
@@ -895,7 +911,7 @@
 </file>
 
 <file path=ppt/notesSlides/notesSlide15.xml><?xml version="1.0" encoding="utf-8"?>
-<p:notes xmlns:a="http://schemas.openxmlformats.org/drawingml/2006/main" xmlns:p="http://schemas.openxmlformats.org/presentationml/2006/main" xmlns:r="http://schemas.openxmlformats.org/officeDocument/2006/relationships">
+<p:notes xmlns:a="http://schemas.openxmlformats.org/drawingml/2006/main" xmlns:r="http://schemas.openxmlformats.org/officeDocument/2006/relationships" xmlns:p="http://schemas.openxmlformats.org/presentationml/2006/main">
   <p:cSld>
     <p:spTree>
       <p:nvGrpSpPr>
@@ -930,7 +946,7 @@
             <a:spLocks noGrp="1"/>
           </p:cNvSpPr>
           <p:nvPr>
-            <p:ph type="body" idx="3" sz="quarter"/>
+            <p:ph type="body" sz="quarter" idx="3"/>
           </p:nvPr>
         </p:nvSpPr>
         <p:spPr/>
@@ -951,7 +967,7 @@
             <a:spLocks noGrp="1"/>
           </p:cNvSpPr>
           <p:nvPr>
-            <p:ph type="sldNum" idx="5" sz="quarter"/>
+            <p:ph type="sldNum" sz="quarter" idx="5"/>
           </p:nvPr>
         </p:nvSpPr>
         <p:spPr/>
@@ -965,7 +981,7 @@
 </file>
 
 <file path=ppt/notesSlides/notesSlide16.xml><?xml version="1.0" encoding="utf-8"?>
-<p:notes xmlns:a="http://schemas.openxmlformats.org/drawingml/2006/main" xmlns:p="http://schemas.openxmlformats.org/presentationml/2006/main" xmlns:r="http://schemas.openxmlformats.org/officeDocument/2006/relationships">
+<p:notes xmlns:a="http://schemas.openxmlformats.org/drawingml/2006/main" xmlns:r="http://schemas.openxmlformats.org/officeDocument/2006/relationships" xmlns:p="http://schemas.openxmlformats.org/presentationml/2006/main">
   <p:cSld>
     <p:spTree>
       <p:nvGrpSpPr>
@@ -1000,7 +1016,7 @@
             <a:spLocks noGrp="1"/>
           </p:cNvSpPr>
           <p:nvPr>
-            <p:ph type="body" idx="3" sz="quarter"/>
+            <p:ph type="body" sz="quarter" idx="3"/>
           </p:nvPr>
         </p:nvSpPr>
         <p:spPr/>
@@ -1021,7 +1037,7 @@
             <a:spLocks noGrp="1"/>
           </p:cNvSpPr>
           <p:nvPr>
-            <p:ph type="sldNum" idx="5" sz="quarter"/>
+            <p:ph type="sldNum" sz="quarter" idx="5"/>
           </p:nvPr>
         </p:nvSpPr>
         <p:spPr/>
@@ -1035,7 +1051,7 @@
 </file>
 
 <file path=ppt/notesSlides/notesSlide17.xml><?xml version="1.0" encoding="utf-8"?>
-<p:notes xmlns:a="http://schemas.openxmlformats.org/drawingml/2006/main" xmlns:p="http://schemas.openxmlformats.org/presentationml/2006/main" xmlns:r="http://schemas.openxmlformats.org/officeDocument/2006/relationships">
+<p:notes xmlns:a="http://schemas.openxmlformats.org/drawingml/2006/main" xmlns:r="http://schemas.openxmlformats.org/officeDocument/2006/relationships" xmlns:p="http://schemas.openxmlformats.org/presentationml/2006/main">
   <p:cSld>
     <p:spTree>
       <p:nvGrpSpPr>
@@ -1070,7 +1086,7 @@
             <a:spLocks noGrp="1"/>
           </p:cNvSpPr>
           <p:nvPr>
-            <p:ph type="body" idx="3" sz="quarter"/>
+            <p:ph type="body" sz="quarter" idx="3"/>
           </p:nvPr>
         </p:nvSpPr>
         <p:spPr/>
@@ -1091,7 +1107,7 @@
             <a:spLocks noGrp="1"/>
           </p:cNvSpPr>
           <p:nvPr>
-            <p:ph type="sldNum" idx="5" sz="quarter"/>
+            <p:ph type="sldNum" sz="quarter" idx="5"/>
           </p:nvPr>
         </p:nvSpPr>
         <p:spPr/>
@@ -1105,7 +1121,7 @@
 </file>
 
 <file path=ppt/notesSlides/notesSlide18.xml><?xml version="1.0" encoding="utf-8"?>
-<p:notes xmlns:a="http://schemas.openxmlformats.org/drawingml/2006/main" xmlns:p="http://schemas.openxmlformats.org/presentationml/2006/main" xmlns:r="http://schemas.openxmlformats.org/officeDocument/2006/relationships">
+<p:notes xmlns:a="http://schemas.openxmlformats.org/drawingml/2006/main" xmlns:r="http://schemas.openxmlformats.org/officeDocument/2006/relationships" xmlns:p="http://schemas.openxmlformats.org/presentationml/2006/main">
   <p:cSld>
     <p:spTree>
       <p:nvGrpSpPr>
@@ -1140,7 +1156,7 @@
             <a:spLocks noGrp="1"/>
           </p:cNvSpPr>
           <p:nvPr>
-            <p:ph type="body" idx="3" sz="quarter"/>
+            <p:ph type="body" sz="quarter" idx="3"/>
           </p:nvPr>
         </p:nvSpPr>
         <p:spPr/>
@@ -1161,7 +1177,7 @@
             <a:spLocks noGrp="1"/>
           </p:cNvSpPr>
           <p:nvPr>
-            <p:ph type="sldNum" idx="5" sz="quarter"/>
+            <p:ph type="sldNum" sz="quarter" idx="5"/>
           </p:nvPr>
         </p:nvSpPr>
         <p:spPr/>
@@ -1175,7 +1191,7 @@
 </file>
 
 <file path=ppt/notesSlides/notesSlide2.xml><?xml version="1.0" encoding="utf-8"?>
-<p:notes xmlns:a="http://schemas.openxmlformats.org/drawingml/2006/main" xmlns:p="http://schemas.openxmlformats.org/presentationml/2006/main" xmlns:r="http://schemas.openxmlformats.org/officeDocument/2006/relationships">
+<p:notes xmlns:a="http://schemas.openxmlformats.org/drawingml/2006/main" xmlns:r="http://schemas.openxmlformats.org/officeDocument/2006/relationships" xmlns:p="http://schemas.openxmlformats.org/presentationml/2006/main">
   <p:cSld>
     <p:spTree>
       <p:nvGrpSpPr>
@@ -1210,7 +1226,7 @@
             <a:spLocks noGrp="1"/>
           </p:cNvSpPr>
           <p:nvPr>
-            <p:ph type="body" idx="3" sz="quarter"/>
+            <p:ph type="body" sz="quarter" idx="3"/>
           </p:nvPr>
         </p:nvSpPr>
         <p:spPr/>
@@ -1219,7 +1235,7 @@
           <a:lstStyle/>
           <a:p>
             <a:r>
-              <a:t>This presentation is prepared by Barathkumar M and Subash P. Barathkumar handled the security pipeline and PII detection algorithms, while Subash built the Python Flask backend and the interactive dashboard.</a:t>
+              <a:t>This presentation is prepared by Barathkumar M and Subash P. Barathkumar handled the security pipeline and PII detection algorithms, while Subash built the Python backend and the interactive dashboard.</a:t>
             </a:r>
           </a:p>
         </p:txBody>
@@ -1231,7 +1247,7 @@
             <a:spLocks noGrp="1"/>
           </p:cNvSpPr>
           <p:nvPr>
-            <p:ph type="sldNum" idx="5" sz="quarter"/>
+            <p:ph type="sldNum" sz="quarter" idx="5"/>
           </p:nvPr>
         </p:nvSpPr>
         <p:spPr/>
@@ -1245,7 +1261,7 @@
 </file>
 
 <file path=ppt/notesSlides/notesSlide3.xml><?xml version="1.0" encoding="utf-8"?>
-<p:notes xmlns:a="http://schemas.openxmlformats.org/drawingml/2006/main" xmlns:p="http://schemas.openxmlformats.org/presentationml/2006/main" xmlns:r="http://schemas.openxmlformats.org/officeDocument/2006/relationships">
+<p:notes xmlns:a="http://schemas.openxmlformats.org/drawingml/2006/main" xmlns:r="http://schemas.openxmlformats.org/officeDocument/2006/relationships" xmlns:p="http://schemas.openxmlformats.org/presentationml/2006/main">
   <p:cSld>
     <p:spTree>
       <p:nvGrpSpPr>
@@ -1280,7 +1296,7 @@
             <a:spLocks noGrp="1"/>
           </p:cNvSpPr>
           <p:nvPr>
-            <p:ph type="body" idx="3" sz="quarter"/>
+            <p:ph type="body" sz="quarter" idx="3"/>
           </p:nvPr>
         </p:nvSpPr>
         <p:spPr/>
@@ -1301,7 +1317,7 @@
             <a:spLocks noGrp="1"/>
           </p:cNvSpPr>
           <p:nvPr>
-            <p:ph type="sldNum" idx="5" sz="quarter"/>
+            <p:ph type="sldNum" sz="quarter" idx="5"/>
           </p:nvPr>
         </p:nvSpPr>
         <p:spPr/>
@@ -1315,7 +1331,7 @@
 </file>
 
 <file path=ppt/notesSlides/notesSlide4.xml><?xml version="1.0" encoding="utf-8"?>
-<p:notes xmlns:a="http://schemas.openxmlformats.org/drawingml/2006/main" xmlns:p="http://schemas.openxmlformats.org/presentationml/2006/main" xmlns:r="http://schemas.openxmlformats.org/officeDocument/2006/relationships">
+<p:notes xmlns:a="http://schemas.openxmlformats.org/drawingml/2006/main" xmlns:r="http://schemas.openxmlformats.org/officeDocument/2006/relationships" xmlns:p="http://schemas.openxmlformats.org/presentationml/2006/main">
   <p:cSld>
     <p:spTree>
       <p:nvGrpSpPr>
@@ -1350,7 +1366,7 @@
             <a:spLocks noGrp="1"/>
           </p:cNvSpPr>
           <p:nvPr>
-            <p:ph type="body" idx="3" sz="quarter"/>
+            <p:ph type="body" sz="quarter" idx="3"/>
           </p:nvPr>
         </p:nvSpPr>
         <p:spPr/>
@@ -1371,7 +1387,7 @@
             <a:spLocks noGrp="1"/>
           </p:cNvSpPr>
           <p:nvPr>
-            <p:ph type="sldNum" idx="5" sz="quarter"/>
+            <p:ph type="sldNum" sz="quarter" idx="5"/>
           </p:nvPr>
         </p:nvSpPr>
         <p:spPr/>
@@ -1385,7 +1401,7 @@
 </file>
 
 <file path=ppt/notesSlides/notesSlide5.xml><?xml version="1.0" encoding="utf-8"?>
-<p:notes xmlns:a="http://schemas.openxmlformats.org/drawingml/2006/main" xmlns:p="http://schemas.openxmlformats.org/presentationml/2006/main" xmlns:r="http://schemas.openxmlformats.org/officeDocument/2006/relationships">
+<p:notes xmlns:a="http://schemas.openxmlformats.org/drawingml/2006/main" xmlns:r="http://schemas.openxmlformats.org/officeDocument/2006/relationships" xmlns:p="http://schemas.openxmlformats.org/presentationml/2006/main">
   <p:cSld>
     <p:spTree>
       <p:nvGrpSpPr>
@@ -1420,7 +1436,7 @@
             <a:spLocks noGrp="1"/>
           </p:cNvSpPr>
           <p:nvPr>
-            <p:ph type="body" idx="3" sz="quarter"/>
+            <p:ph type="body" sz="quarter" idx="3"/>
           </p:nvPr>
         </p:nvSpPr>
         <p:spPr/>
@@ -1441,7 +1457,7 @@
             <a:spLocks noGrp="1"/>
           </p:cNvSpPr>
           <p:nvPr>
-            <p:ph type="sldNum" idx="5" sz="quarter"/>
+            <p:ph type="sldNum" sz="quarter" idx="5"/>
           </p:nvPr>
         </p:nvSpPr>
         <p:spPr/>
@@ -1455,7 +1471,7 @@
 </file>
 
 <file path=ppt/notesSlides/notesSlide6.xml><?xml version="1.0" encoding="utf-8"?>
-<p:notes xmlns:a="http://schemas.openxmlformats.org/drawingml/2006/main" xmlns:p="http://schemas.openxmlformats.org/presentationml/2006/main" xmlns:r="http://schemas.openxmlformats.org/officeDocument/2006/relationships">
+<p:notes xmlns:a="http://schemas.openxmlformats.org/drawingml/2006/main" xmlns:r="http://schemas.openxmlformats.org/officeDocument/2006/relationships" xmlns:p="http://schemas.openxmlformats.org/presentationml/2006/main">
   <p:cSld>
     <p:spTree>
       <p:nvGrpSpPr>
@@ -1490,7 +1506,7 @@
             <a:spLocks noGrp="1"/>
           </p:cNvSpPr>
           <p:nvPr>
-            <p:ph type="body" idx="3" sz="quarter"/>
+            <p:ph type="body" sz="quarter" idx="3"/>
           </p:nvPr>
         </p:nvSpPr>
         <p:spPr/>
@@ -1511,7 +1527,7 @@
             <a:spLocks noGrp="1"/>
           </p:cNvSpPr>
           <p:nvPr>
-            <p:ph type="sldNum" idx="5" sz="quarter"/>
+            <p:ph type="sldNum" sz="quarter" idx="5"/>
           </p:nvPr>
         </p:nvSpPr>
         <p:spPr/>
@@ -1525,7 +1541,7 @@
 </file>
 
 <file path=ppt/notesSlides/notesSlide7.xml><?xml version="1.0" encoding="utf-8"?>
-<p:notes xmlns:a="http://schemas.openxmlformats.org/drawingml/2006/main" xmlns:p="http://schemas.openxmlformats.org/presentationml/2006/main" xmlns:r="http://schemas.openxmlformats.org/officeDocument/2006/relationships">
+<p:notes xmlns:a="http://schemas.openxmlformats.org/drawingml/2006/main" xmlns:r="http://schemas.openxmlformats.org/officeDocument/2006/relationships" xmlns:p="http://schemas.openxmlformats.org/presentationml/2006/main">
   <p:cSld>
     <p:spTree>
       <p:nvGrpSpPr>
@@ -1560,7 +1576,7 @@
             <a:spLocks noGrp="1"/>
           </p:cNvSpPr>
           <p:nvPr>
-            <p:ph type="body" idx="3" sz="quarter"/>
+            <p:ph type="body" sz="quarter" idx="3"/>
           </p:nvPr>
         </p:nvSpPr>
         <p:spPr/>
@@ -1581,7 +1597,7 @@
             <a:spLocks noGrp="1"/>
           </p:cNvSpPr>
           <p:nvPr>
-            <p:ph type="sldNum" idx="5" sz="quarter"/>
+            <p:ph type="sldNum" sz="quarter" idx="5"/>
           </p:nvPr>
         </p:nvSpPr>
         <p:spPr/>
@@ -1595,7 +1611,7 @@
 </file>
 
 <file path=ppt/notesSlides/notesSlide8.xml><?xml version="1.0" encoding="utf-8"?>
-<p:notes xmlns:a="http://schemas.openxmlformats.org/drawingml/2006/main" xmlns:p="http://schemas.openxmlformats.org/presentationml/2006/main" xmlns:r="http://schemas.openxmlformats.org/officeDocument/2006/relationships">
+<p:notes xmlns:a="http://schemas.openxmlformats.org/drawingml/2006/main" xmlns:r="http://schemas.openxmlformats.org/officeDocument/2006/relationships" xmlns:p="http://schemas.openxmlformats.org/presentationml/2006/main">
   <p:cSld>
     <p:spTree>
       <p:nvGrpSpPr>
@@ -1630,7 +1646,7 @@
             <a:spLocks noGrp="1"/>
           </p:cNvSpPr>
           <p:nvPr>
-            <p:ph type="body" idx="3" sz="quarter"/>
+            <p:ph type="body" sz="quarter" idx="3"/>
           </p:nvPr>
         </p:nvSpPr>
         <p:spPr/>
@@ -1651,7 +1667,7 @@
             <a:spLocks noGrp="1"/>
           </p:cNvSpPr>
           <p:nvPr>
-            <p:ph type="sldNum" idx="5" sz="quarter"/>
+            <p:ph type="sldNum" sz="quarter" idx="5"/>
           </p:nvPr>
         </p:nvSpPr>
         <p:spPr/>
@@ -1665,7 +1681,7 @@
 </file>
 
 <file path=ppt/notesSlides/notesSlide9.xml><?xml version="1.0" encoding="utf-8"?>
-<p:notes xmlns:a="http://schemas.openxmlformats.org/drawingml/2006/main" xmlns:p="http://schemas.openxmlformats.org/presentationml/2006/main" xmlns:r="http://schemas.openxmlformats.org/officeDocument/2006/relationships">
+<p:notes xmlns:a="http://schemas.openxmlformats.org/drawingml/2006/main" xmlns:r="http://schemas.openxmlformats.org/officeDocument/2006/relationships" xmlns:p="http://schemas.openxmlformats.org/presentationml/2006/main">
   <p:cSld>
     <p:spTree>
       <p:nvGrpSpPr>
@@ -1700,7 +1716,7 @@
             <a:spLocks noGrp="1"/>
           </p:cNvSpPr>
           <p:nvPr>
-            <p:ph type="body" idx="3" sz="quarter"/>
+            <p:ph type="body" sz="quarter" idx="3"/>
           </p:nvPr>
         </p:nvSpPr>
         <p:spPr/>
@@ -1721,7 +1737,7 @@
             <a:spLocks noGrp="1"/>
           </p:cNvSpPr>
           <p:nvPr>
-            <p:ph type="sldNum" idx="5" sz="quarter"/>
+            <p:ph type="sldNum" sz="quarter" idx="5"/>
           </p:nvPr>
         </p:nvSpPr>
         <p:spPr/>
@@ -1915,7 +1931,6 @@
           <a:p>
             <a:fld id="{5BCAD085-E8A6-8845-BD4E-CB4CCA059FC4}" type="datetimeFigureOut">
               <a:rPr lang="en-US" smtClean="0"/>
-              <a:t>1/27/13</a:t>
             </a:fld>
             <a:endParaRPr lang="en-US"/>
           </a:p>
@@ -1957,18 +1972,12 @@
           <a:p>
             <a:fld id="{C1FF6DA9-008F-8B48-92A6-B652298478BF}" type="slidenum">
               <a:rPr lang="en-US" smtClean="0"/>
-              <a:t>‹#›</a:t>
             </a:fld>
             <a:endParaRPr lang="en-US"/>
           </a:p>
         </p:txBody>
       </p:sp>
     </p:spTree>
-    <p:extLst>
-      <p:ext uri="{BB962C8B-B14F-4D97-AF65-F5344CB8AC3E}">
-        <p14:creationId xmlns:p14="http://schemas.microsoft.com/office/powerpoint/2010/main" val="3168075583"/>
-      </p:ext>
-    </p:extLst>
   </p:cSld>
   <p:clrMapOvr>
     <a:masterClrMapping/>
@@ -2036,6 +2045,7 @@
               <a:rPr lang="en-US" smtClean="0"/>
               <a:t>Click to edit Master text styles</a:t>
             </a:r>
+            <a:endParaRPr lang="en-US" smtClean="0"/>
           </a:p>
           <a:p>
             <a:pPr lvl="1"/>
@@ -2043,6 +2053,7 @@
               <a:rPr lang="en-US" smtClean="0"/>
               <a:t>Second level</a:t>
             </a:r>
+            <a:endParaRPr lang="en-US" smtClean="0"/>
           </a:p>
           <a:p>
             <a:pPr lvl="2"/>
@@ -2050,6 +2061,7 @@
               <a:rPr lang="en-US" smtClean="0"/>
               <a:t>Third level</a:t>
             </a:r>
+            <a:endParaRPr lang="en-US" smtClean="0"/>
           </a:p>
           <a:p>
             <a:pPr lvl="3"/>
@@ -2057,6 +2069,7 @@
               <a:rPr lang="en-US" smtClean="0"/>
               <a:t>Fourth level</a:t>
             </a:r>
+            <a:endParaRPr lang="en-US" smtClean="0"/>
           </a:p>
           <a:p>
             <a:pPr lvl="4"/>
@@ -2085,7 +2098,6 @@
           <a:p>
             <a:fld id="{5BCAD085-E8A6-8845-BD4E-CB4CCA059FC4}" type="datetimeFigureOut">
               <a:rPr lang="en-US" smtClean="0"/>
-              <a:t>1/27/13</a:t>
             </a:fld>
             <a:endParaRPr lang="en-US"/>
           </a:p>
@@ -2127,18 +2139,12 @@
           <a:p>
             <a:fld id="{C1FF6DA9-008F-8B48-92A6-B652298478BF}" type="slidenum">
               <a:rPr lang="en-US" smtClean="0"/>
-              <a:t>‹#›</a:t>
             </a:fld>
             <a:endParaRPr lang="en-US"/>
           </a:p>
         </p:txBody>
       </p:sp>
     </p:spTree>
-    <p:extLst>
-      <p:ext uri="{BB962C8B-B14F-4D97-AF65-F5344CB8AC3E}">
-        <p14:creationId xmlns:p14="http://schemas.microsoft.com/office/powerpoint/2010/main" val="2910927964"/>
-      </p:ext>
-    </p:extLst>
   </p:cSld>
   <p:clrMapOvr>
     <a:masterClrMapping/>
@@ -2216,6 +2222,7 @@
               <a:rPr lang="en-US" smtClean="0"/>
               <a:t>Click to edit Master text styles</a:t>
             </a:r>
+            <a:endParaRPr lang="en-US" smtClean="0"/>
           </a:p>
           <a:p>
             <a:pPr lvl="1"/>
@@ -2223,6 +2230,7 @@
               <a:rPr lang="en-US" smtClean="0"/>
               <a:t>Second level</a:t>
             </a:r>
+            <a:endParaRPr lang="en-US" smtClean="0"/>
           </a:p>
           <a:p>
             <a:pPr lvl="2"/>
@@ -2230,6 +2238,7 @@
               <a:rPr lang="en-US" smtClean="0"/>
               <a:t>Third level</a:t>
             </a:r>
+            <a:endParaRPr lang="en-US" smtClean="0"/>
           </a:p>
           <a:p>
             <a:pPr lvl="3"/>
@@ -2237,6 +2246,7 @@
               <a:rPr lang="en-US" smtClean="0"/>
               <a:t>Fourth level</a:t>
             </a:r>
+            <a:endParaRPr lang="en-US" smtClean="0"/>
           </a:p>
           <a:p>
             <a:pPr lvl="4"/>
@@ -2265,7 +2275,6 @@
           <a:p>
             <a:fld id="{5BCAD085-E8A6-8845-BD4E-CB4CCA059FC4}" type="datetimeFigureOut">
               <a:rPr lang="en-US" smtClean="0"/>
-              <a:t>1/27/13</a:t>
             </a:fld>
             <a:endParaRPr lang="en-US"/>
           </a:p>
@@ -2307,18 +2316,12 @@
           <a:p>
             <a:fld id="{C1FF6DA9-008F-8B48-92A6-B652298478BF}" type="slidenum">
               <a:rPr lang="en-US" smtClean="0"/>
-              <a:t>‹#›</a:t>
             </a:fld>
             <a:endParaRPr lang="en-US"/>
           </a:p>
         </p:txBody>
       </p:sp>
     </p:spTree>
-    <p:extLst>
-      <p:ext uri="{BB962C8B-B14F-4D97-AF65-F5344CB8AC3E}">
-        <p14:creationId xmlns:p14="http://schemas.microsoft.com/office/powerpoint/2010/main" val="3612223792"/>
-      </p:ext>
-    </p:extLst>
   </p:cSld>
   <p:clrMapOvr>
     <a:masterClrMapping/>
@@ -2386,6 +2389,7 @@
               <a:rPr lang="en-US" smtClean="0"/>
               <a:t>Click to edit Master text styles</a:t>
             </a:r>
+            <a:endParaRPr lang="en-US" smtClean="0"/>
           </a:p>
           <a:p>
             <a:pPr lvl="1"/>
@@ -2393,6 +2397,7 @@
               <a:rPr lang="en-US" smtClean="0"/>
               <a:t>Second level</a:t>
             </a:r>
+            <a:endParaRPr lang="en-US" smtClean="0"/>
           </a:p>
           <a:p>
             <a:pPr lvl="2"/>
@@ -2400,6 +2405,7 @@
               <a:rPr lang="en-US" smtClean="0"/>
               <a:t>Third level</a:t>
             </a:r>
+            <a:endParaRPr lang="en-US" smtClean="0"/>
           </a:p>
           <a:p>
             <a:pPr lvl="3"/>
@@ -2407,6 +2413,7 @@
               <a:rPr lang="en-US" smtClean="0"/>
               <a:t>Fourth level</a:t>
             </a:r>
+            <a:endParaRPr lang="en-US" smtClean="0"/>
           </a:p>
           <a:p>
             <a:pPr lvl="4"/>
@@ -2435,7 +2442,6 @@
           <a:p>
             <a:fld id="{5BCAD085-E8A6-8845-BD4E-CB4CCA059FC4}" type="datetimeFigureOut">
               <a:rPr lang="en-US" smtClean="0"/>
-              <a:t>1/27/13</a:t>
             </a:fld>
             <a:endParaRPr lang="en-US"/>
           </a:p>
@@ -2477,18 +2483,12 @@
           <a:p>
             <a:fld id="{C1FF6DA9-008F-8B48-92A6-B652298478BF}" type="slidenum">
               <a:rPr lang="en-US" smtClean="0"/>
-              <a:t>‹#›</a:t>
             </a:fld>
             <a:endParaRPr lang="en-US"/>
           </a:p>
         </p:txBody>
       </p:sp>
     </p:spTree>
-    <p:extLst>
-      <p:ext uri="{BB962C8B-B14F-4D97-AF65-F5344CB8AC3E}">
-        <p14:creationId xmlns:p14="http://schemas.microsoft.com/office/powerpoint/2010/main" val="2614314258"/>
-      </p:ext>
-    </p:extLst>
   </p:cSld>
   <p:clrMapOvr>
     <a:masterClrMapping/>
@@ -2661,6 +2661,7 @@
               <a:rPr lang="en-US" smtClean="0"/>
               <a:t>Click to edit Master text styles</a:t>
             </a:r>
+            <a:endParaRPr lang="en-US" smtClean="0"/>
           </a:p>
         </p:txBody>
       </p:sp>
@@ -2681,7 +2682,6 @@
           <a:p>
             <a:fld id="{5BCAD085-E8A6-8845-BD4E-CB4CCA059FC4}" type="datetimeFigureOut">
               <a:rPr lang="en-US" smtClean="0"/>
-              <a:t>1/27/13</a:t>
             </a:fld>
             <a:endParaRPr lang="en-US"/>
           </a:p>
@@ -2723,18 +2723,12 @@
           <a:p>
             <a:fld id="{C1FF6DA9-008F-8B48-92A6-B652298478BF}" type="slidenum">
               <a:rPr lang="en-US" smtClean="0"/>
-              <a:t>‹#›</a:t>
             </a:fld>
             <a:endParaRPr lang="en-US"/>
           </a:p>
         </p:txBody>
       </p:sp>
     </p:spTree>
-    <p:extLst>
-      <p:ext uri="{BB962C8B-B14F-4D97-AF65-F5344CB8AC3E}">
-        <p14:creationId xmlns:p14="http://schemas.microsoft.com/office/powerpoint/2010/main" val="960648375"/>
-      </p:ext>
-    </p:extLst>
   </p:cSld>
   <p:clrMapOvr>
     <a:masterClrMapping/>
@@ -2835,6 +2829,7 @@
               <a:rPr lang="en-US" smtClean="0"/>
               <a:t>Click to edit Master text styles</a:t>
             </a:r>
+            <a:endParaRPr lang="en-US" smtClean="0"/>
           </a:p>
           <a:p>
             <a:pPr lvl="1"/>
@@ -2842,6 +2837,7 @@
               <a:rPr lang="en-US" smtClean="0"/>
               <a:t>Second level</a:t>
             </a:r>
+            <a:endParaRPr lang="en-US" smtClean="0"/>
           </a:p>
           <a:p>
             <a:pPr lvl="2"/>
@@ -2849,6 +2845,7 @@
               <a:rPr lang="en-US" smtClean="0"/>
               <a:t>Third level</a:t>
             </a:r>
+            <a:endParaRPr lang="en-US" smtClean="0"/>
           </a:p>
           <a:p>
             <a:pPr lvl="3"/>
@@ -2856,6 +2853,7 @@
               <a:rPr lang="en-US" smtClean="0"/>
               <a:t>Fourth level</a:t>
             </a:r>
+            <a:endParaRPr lang="en-US" smtClean="0"/>
           </a:p>
           <a:p>
             <a:pPr lvl="4"/>
@@ -2920,6 +2918,7 @@
               <a:rPr lang="en-US" smtClean="0"/>
               <a:t>Click to edit Master text styles</a:t>
             </a:r>
+            <a:endParaRPr lang="en-US" smtClean="0"/>
           </a:p>
           <a:p>
             <a:pPr lvl="1"/>
@@ -2927,6 +2926,7 @@
               <a:rPr lang="en-US" smtClean="0"/>
               <a:t>Second level</a:t>
             </a:r>
+            <a:endParaRPr lang="en-US" smtClean="0"/>
           </a:p>
           <a:p>
             <a:pPr lvl="2"/>
@@ -2934,6 +2934,7 @@
               <a:rPr lang="en-US" smtClean="0"/>
               <a:t>Third level</a:t>
             </a:r>
+            <a:endParaRPr lang="en-US" smtClean="0"/>
           </a:p>
           <a:p>
             <a:pPr lvl="3"/>
@@ -2941,6 +2942,7 @@
               <a:rPr lang="en-US" smtClean="0"/>
               <a:t>Fourth level</a:t>
             </a:r>
+            <a:endParaRPr lang="en-US" smtClean="0"/>
           </a:p>
           <a:p>
             <a:pPr lvl="4"/>
@@ -2969,7 +2971,6 @@
           <a:p>
             <a:fld id="{5BCAD085-E8A6-8845-BD4E-CB4CCA059FC4}" type="datetimeFigureOut">
               <a:rPr lang="en-US" smtClean="0"/>
-              <a:t>1/27/13</a:t>
             </a:fld>
             <a:endParaRPr lang="en-US"/>
           </a:p>
@@ -3011,18 +3012,12 @@
           <a:p>
             <a:fld id="{C1FF6DA9-008F-8B48-92A6-B652298478BF}" type="slidenum">
               <a:rPr lang="en-US" smtClean="0"/>
-              <a:t>‹#›</a:t>
             </a:fld>
             <a:endParaRPr lang="en-US"/>
           </a:p>
         </p:txBody>
       </p:sp>
     </p:spTree>
-    <p:extLst>
-      <p:ext uri="{BB962C8B-B14F-4D97-AF65-F5344CB8AC3E}">
-        <p14:creationId xmlns:p14="http://schemas.microsoft.com/office/powerpoint/2010/main" val="2782244947"/>
-      </p:ext>
-    </p:extLst>
   </p:cSld>
   <p:clrMapOvr>
     <a:masterClrMapping/>
@@ -3136,6 +3131,7 @@
               <a:rPr lang="en-US" smtClean="0"/>
               <a:t>Click to edit Master text styles</a:t>
             </a:r>
+            <a:endParaRPr lang="en-US" smtClean="0"/>
           </a:p>
         </p:txBody>
       </p:sp>
@@ -3192,6 +3188,7 @@
               <a:rPr lang="en-US" smtClean="0"/>
               <a:t>Click to edit Master text styles</a:t>
             </a:r>
+            <a:endParaRPr lang="en-US" smtClean="0"/>
           </a:p>
           <a:p>
             <a:pPr lvl="1"/>
@@ -3199,6 +3196,7 @@
               <a:rPr lang="en-US" smtClean="0"/>
               <a:t>Second level</a:t>
             </a:r>
+            <a:endParaRPr lang="en-US" smtClean="0"/>
           </a:p>
           <a:p>
             <a:pPr lvl="2"/>
@@ -3206,6 +3204,7 @@
               <a:rPr lang="en-US" smtClean="0"/>
               <a:t>Third level</a:t>
             </a:r>
+            <a:endParaRPr lang="en-US" smtClean="0"/>
           </a:p>
           <a:p>
             <a:pPr lvl="3"/>
@@ -3213,6 +3212,7 @@
               <a:rPr lang="en-US" smtClean="0"/>
               <a:t>Fourth level</a:t>
             </a:r>
+            <a:endParaRPr lang="en-US" smtClean="0"/>
           </a:p>
           <a:p>
             <a:pPr lvl="4"/>
@@ -3286,6 +3286,7 @@
               <a:rPr lang="en-US" smtClean="0"/>
               <a:t>Click to edit Master text styles</a:t>
             </a:r>
+            <a:endParaRPr lang="en-US" smtClean="0"/>
           </a:p>
         </p:txBody>
       </p:sp>
@@ -3342,6 +3343,7 @@
               <a:rPr lang="en-US" smtClean="0"/>
               <a:t>Click to edit Master text styles</a:t>
             </a:r>
+            <a:endParaRPr lang="en-US" smtClean="0"/>
           </a:p>
           <a:p>
             <a:pPr lvl="1"/>
@@ -3349,6 +3351,7 @@
               <a:rPr lang="en-US" smtClean="0"/>
               <a:t>Second level</a:t>
             </a:r>
+            <a:endParaRPr lang="en-US" smtClean="0"/>
           </a:p>
           <a:p>
             <a:pPr lvl="2"/>
@@ -3356,6 +3359,7 @@
               <a:rPr lang="en-US" smtClean="0"/>
               <a:t>Third level</a:t>
             </a:r>
+            <a:endParaRPr lang="en-US" smtClean="0"/>
           </a:p>
           <a:p>
             <a:pPr lvl="3"/>
@@ -3363,6 +3367,7 @@
               <a:rPr lang="en-US" smtClean="0"/>
               <a:t>Fourth level</a:t>
             </a:r>
+            <a:endParaRPr lang="en-US" smtClean="0"/>
           </a:p>
           <a:p>
             <a:pPr lvl="4"/>
@@ -3391,7 +3396,6 @@
           <a:p>
             <a:fld id="{5BCAD085-E8A6-8845-BD4E-CB4CCA059FC4}" type="datetimeFigureOut">
               <a:rPr lang="en-US" smtClean="0"/>
-              <a:t>1/27/13</a:t>
             </a:fld>
             <a:endParaRPr lang="en-US"/>
           </a:p>
@@ -3433,18 +3437,12 @@
           <a:p>
             <a:fld id="{C1FF6DA9-008F-8B48-92A6-B652298478BF}" type="slidenum">
               <a:rPr lang="en-US" smtClean="0"/>
-              <a:t>‹#›</a:t>
             </a:fld>
             <a:endParaRPr lang="en-US"/>
           </a:p>
         </p:txBody>
       </p:sp>
     </p:spTree>
-    <p:extLst>
-      <p:ext uri="{BB962C8B-B14F-4D97-AF65-F5344CB8AC3E}">
-        <p14:creationId xmlns:p14="http://schemas.microsoft.com/office/powerpoint/2010/main" val="990158736"/>
-      </p:ext>
-    </p:extLst>
   </p:cSld>
   <p:clrMapOvr>
     <a:masterClrMapping/>
@@ -3509,7 +3507,6 @@
           <a:p>
             <a:fld id="{5BCAD085-E8A6-8845-BD4E-CB4CCA059FC4}" type="datetimeFigureOut">
               <a:rPr lang="en-US" smtClean="0"/>
-              <a:t>1/27/13</a:t>
             </a:fld>
             <a:endParaRPr lang="en-US"/>
           </a:p>
@@ -3551,18 +3548,12 @@
           <a:p>
             <a:fld id="{C1FF6DA9-008F-8B48-92A6-B652298478BF}" type="slidenum">
               <a:rPr lang="en-US" smtClean="0"/>
-              <a:t>‹#›</a:t>
             </a:fld>
             <a:endParaRPr lang="en-US"/>
           </a:p>
         </p:txBody>
       </p:sp>
     </p:spTree>
-    <p:extLst>
-      <p:ext uri="{BB962C8B-B14F-4D97-AF65-F5344CB8AC3E}">
-        <p14:creationId xmlns:p14="http://schemas.microsoft.com/office/powerpoint/2010/main" val="727027711"/>
-      </p:ext>
-    </p:extLst>
   </p:cSld>
   <p:clrMapOvr>
     <a:masterClrMapping/>
@@ -3604,7 +3595,6 @@
           <a:p>
             <a:fld id="{5BCAD085-E8A6-8845-BD4E-CB4CCA059FC4}" type="datetimeFigureOut">
               <a:rPr lang="en-US" smtClean="0"/>
-              <a:t>1/27/13</a:t>
             </a:fld>
             <a:endParaRPr lang="en-US"/>
           </a:p>
@@ -3646,18 +3636,12 @@
           <a:p>
             <a:fld id="{C1FF6DA9-008F-8B48-92A6-B652298478BF}" type="slidenum">
               <a:rPr lang="en-US" smtClean="0"/>
-              <a:t>‹#›</a:t>
             </a:fld>
             <a:endParaRPr lang="en-US"/>
           </a:p>
         </p:txBody>
       </p:sp>
     </p:spTree>
-    <p:extLst>
-      <p:ext uri="{BB962C8B-B14F-4D97-AF65-F5344CB8AC3E}">
-        <p14:creationId xmlns:p14="http://schemas.microsoft.com/office/powerpoint/2010/main" val="1212999818"/>
-      </p:ext>
-    </p:extLst>
   </p:cSld>
   <p:clrMapOvr>
     <a:masterClrMapping/>
@@ -3767,6 +3751,7 @@
               <a:rPr lang="en-US" smtClean="0"/>
               <a:t>Click to edit Master text styles</a:t>
             </a:r>
+            <a:endParaRPr lang="en-US" smtClean="0"/>
           </a:p>
           <a:p>
             <a:pPr lvl="1"/>
@@ -3774,6 +3759,7 @@
               <a:rPr lang="en-US" smtClean="0"/>
               <a:t>Second level</a:t>
             </a:r>
+            <a:endParaRPr lang="en-US" smtClean="0"/>
           </a:p>
           <a:p>
             <a:pPr lvl="2"/>
@@ -3781,6 +3767,7 @@
               <a:rPr lang="en-US" smtClean="0"/>
               <a:t>Third level</a:t>
             </a:r>
+            <a:endParaRPr lang="en-US" smtClean="0"/>
           </a:p>
           <a:p>
             <a:pPr lvl="3"/>
@@ -3788,6 +3775,7 @@
               <a:rPr lang="en-US" smtClean="0"/>
               <a:t>Fourth level</a:t>
             </a:r>
+            <a:endParaRPr lang="en-US" smtClean="0"/>
           </a:p>
           <a:p>
             <a:pPr lvl="4"/>
@@ -3861,6 +3849,7 @@
               <a:rPr lang="en-US" smtClean="0"/>
               <a:t>Click to edit Master text styles</a:t>
             </a:r>
+            <a:endParaRPr lang="en-US" smtClean="0"/>
           </a:p>
         </p:txBody>
       </p:sp>
@@ -3881,7 +3870,6 @@
           <a:p>
             <a:fld id="{5BCAD085-E8A6-8845-BD4E-CB4CCA059FC4}" type="datetimeFigureOut">
               <a:rPr lang="en-US" smtClean="0"/>
-              <a:t>1/27/13</a:t>
             </a:fld>
             <a:endParaRPr lang="en-US"/>
           </a:p>
@@ -3923,18 +3911,12 @@
           <a:p>
             <a:fld id="{C1FF6DA9-008F-8B48-92A6-B652298478BF}" type="slidenum">
               <a:rPr lang="en-US" smtClean="0"/>
-              <a:t>‹#›</a:t>
             </a:fld>
             <a:endParaRPr lang="en-US"/>
           </a:p>
         </p:txBody>
       </p:sp>
     </p:spTree>
-    <p:extLst>
-      <p:ext uri="{BB962C8B-B14F-4D97-AF65-F5344CB8AC3E}">
-        <p14:creationId xmlns:p14="http://schemas.microsoft.com/office/powerpoint/2010/main" val="1840726560"/>
-      </p:ext>
-    </p:extLst>
   </p:cSld>
   <p:clrMapOvr>
     <a:masterClrMapping/>
@@ -4114,6 +4096,7 @@
               <a:rPr lang="en-US" smtClean="0"/>
               <a:t>Click to edit Master text styles</a:t>
             </a:r>
+            <a:endParaRPr lang="en-US" smtClean="0"/>
           </a:p>
         </p:txBody>
       </p:sp>
@@ -4134,7 +4117,6 @@
           <a:p>
             <a:fld id="{5BCAD085-E8A6-8845-BD4E-CB4CCA059FC4}" type="datetimeFigureOut">
               <a:rPr lang="en-US" smtClean="0"/>
-              <a:t>1/27/13</a:t>
             </a:fld>
             <a:endParaRPr lang="en-US"/>
           </a:p>
@@ -4176,18 +4158,12 @@
           <a:p>
             <a:fld id="{C1FF6DA9-008F-8B48-92A6-B652298478BF}" type="slidenum">
               <a:rPr lang="en-US" smtClean="0"/>
-              <a:t>‹#›</a:t>
             </a:fld>
             <a:endParaRPr lang="en-US"/>
           </a:p>
         </p:txBody>
       </p:sp>
     </p:spTree>
-    <p:extLst>
-      <p:ext uri="{BB962C8B-B14F-4D97-AF65-F5344CB8AC3E}">
-        <p14:creationId xmlns:p14="http://schemas.microsoft.com/office/powerpoint/2010/main" val="3889236939"/>
-      </p:ext>
-    </p:extLst>
   </p:cSld>
   <p:clrMapOvr>
     <a:masterClrMapping/>
@@ -4280,6 +4256,7 @@
               <a:rPr lang="en-US" smtClean="0"/>
               <a:t>Click to edit Master text styles</a:t>
             </a:r>
+            <a:endParaRPr lang="en-US" smtClean="0"/>
           </a:p>
           <a:p>
             <a:pPr lvl="1"/>
@@ -4287,6 +4264,7 @@
               <a:rPr lang="en-US" smtClean="0"/>
               <a:t>Second level</a:t>
             </a:r>
+            <a:endParaRPr lang="en-US" smtClean="0"/>
           </a:p>
           <a:p>
             <a:pPr lvl="2"/>
@@ -4294,6 +4272,7 @@
               <a:rPr lang="en-US" smtClean="0"/>
               <a:t>Third level</a:t>
             </a:r>
+            <a:endParaRPr lang="en-US" smtClean="0"/>
           </a:p>
           <a:p>
             <a:pPr lvl="3"/>
@@ -4301,6 +4280,7 @@
               <a:rPr lang="en-US" smtClean="0"/>
               <a:t>Fourth level</a:t>
             </a:r>
+            <a:endParaRPr lang="en-US" smtClean="0"/>
           </a:p>
           <a:p>
             <a:pPr lvl="4"/>
@@ -4347,7 +4327,6 @@
           <a:p>
             <a:fld id="{5BCAD085-E8A6-8845-BD4E-CB4CCA059FC4}" type="datetimeFigureOut">
               <a:rPr lang="en-US" smtClean="0"/>
-              <a:t>1/27/13</a:t>
             </a:fld>
             <a:endParaRPr lang="en-US"/>
           </a:p>
@@ -4425,18 +4404,12 @@
           <a:p>
             <a:fld id="{C1FF6DA9-008F-8B48-92A6-B652298478BF}" type="slidenum">
               <a:rPr lang="en-US" smtClean="0"/>
-              <a:t>‹#›</a:t>
             </a:fld>
             <a:endParaRPr lang="en-US"/>
           </a:p>
         </p:txBody>
       </p:sp>
     </p:spTree>
-    <p:extLst>
-      <p:ext uri="{BB962C8B-B14F-4D97-AF65-F5344CB8AC3E}">
-        <p14:creationId xmlns:p14="http://schemas.microsoft.com/office/powerpoint/2010/main" val="2209977519"/>
-      </p:ext>
-    </p:extLst>
   </p:cSld>
   <p:clrMap bg1="lt1" tx1="dk1" bg2="lt2" tx2="dk2" accent1="accent1" accent2="accent2" accent3="accent3" accent4="accent4" accent5="accent5" accent6="accent6" hlink="hlink" folHlink="folHlink"/>
   <p:sldLayoutIdLst>
@@ -4474,7 +4447,7 @@
         <a:spcBef>
           <a:spcPct val="20000"/>
         </a:spcBef>
-        <a:buFont typeface="Arial"/>
+        <a:buFont typeface="Arial" panose="020B0604020202020204"/>
         <a:buChar char="•"/>
         <a:defRPr sz="3200" kern="1200">
           <a:solidFill>
@@ -4489,7 +4462,7 @@
         <a:spcBef>
           <a:spcPct val="20000"/>
         </a:spcBef>
-        <a:buFont typeface="Arial"/>
+        <a:buFont typeface="Arial" panose="020B0604020202020204"/>
         <a:buChar char="–"/>
         <a:defRPr sz="2800" kern="1200">
           <a:solidFill>
@@ -4504,7 +4477,7 @@
         <a:spcBef>
           <a:spcPct val="20000"/>
         </a:spcBef>
-        <a:buFont typeface="Arial"/>
+        <a:buFont typeface="Arial" panose="020B0604020202020204"/>
         <a:buChar char="•"/>
         <a:defRPr sz="2400" kern="1200">
           <a:solidFill>
@@ -4519,7 +4492,7 @@
         <a:spcBef>
           <a:spcPct val="20000"/>
         </a:spcBef>
-        <a:buFont typeface="Arial"/>
+        <a:buFont typeface="Arial" panose="020B0604020202020204"/>
         <a:buChar char="–"/>
         <a:defRPr sz="2000" kern="1200">
           <a:solidFill>
@@ -4534,7 +4507,7 @@
         <a:spcBef>
           <a:spcPct val="20000"/>
         </a:spcBef>
-        <a:buFont typeface="Arial"/>
+        <a:buFont typeface="Arial" panose="020B0604020202020204"/>
         <a:buChar char="»"/>
         <a:defRPr sz="2000" kern="1200">
           <a:solidFill>
@@ -4549,7 +4522,7 @@
         <a:spcBef>
           <a:spcPct val="20000"/>
         </a:spcBef>
-        <a:buFont typeface="Arial"/>
+        <a:buFont typeface="Arial" panose="020B0604020202020204"/>
         <a:buChar char="•"/>
         <a:defRPr sz="2000" kern="1200">
           <a:solidFill>
@@ -4564,7 +4537,7 @@
         <a:spcBef>
           <a:spcPct val="20000"/>
         </a:spcBef>
-        <a:buFont typeface="Arial"/>
+        <a:buFont typeface="Arial" panose="020B0604020202020204"/>
         <a:buChar char="•"/>
         <a:defRPr sz="2000" kern="1200">
           <a:solidFill>
@@ -4579,7 +4552,7 @@
         <a:spcBef>
           <a:spcPct val="20000"/>
         </a:spcBef>
-        <a:buFont typeface="Arial"/>
+        <a:buFont typeface="Arial" panose="020B0604020202020204"/>
         <a:buChar char="•"/>
         <a:defRPr sz="2000" kern="1200">
           <a:solidFill>
@@ -4594,7 +4567,7 @@
         <a:spcBef>
           <a:spcPct val="20000"/>
         </a:spcBef>
-        <a:buFont typeface="Arial"/>
+        <a:buFont typeface="Arial" panose="020B0604020202020204"/>
         <a:buChar char="•"/>
         <a:defRPr sz="2000" kern="1200">
           <a:solidFill>
@@ -4706,7 +4679,7 @@
 </file>
 
 <file path=ppt/slides/slide1.xml><?xml version="1.0" encoding="utf-8"?>
-<p:sld xmlns:a="http://schemas.openxmlformats.org/drawingml/2006/main" xmlns:p="http://schemas.openxmlformats.org/presentationml/2006/main" xmlns:r="http://schemas.openxmlformats.org/officeDocument/2006/relationships">
+<p:sld xmlns:a="http://schemas.openxmlformats.org/drawingml/2006/main" xmlns:r="http://schemas.openxmlformats.org/officeDocument/2006/relationships" xmlns:p="http://schemas.openxmlformats.org/presentationml/2006/main">
   <p:cSld>
     <p:spTree>
       <p:nvGrpSpPr>
@@ -4766,8 +4739,8 @@
         </p:nvSpPr>
         <p:spPr>
           <a:xfrm>
-            <a:off x="914400" y="914400"/>
-            <a:ext cx="10362895" cy="5029200"/>
+            <a:off x="731520" y="731520"/>
+            <a:ext cx="10728655" cy="5394960"/>
           </a:xfrm>
           <a:prstGeom prst="roundRect">
             <a:avLst/>
@@ -4811,8 +4784,8 @@
         </p:nvSpPr>
         <p:spPr>
           <a:xfrm>
-            <a:off x="1371600" y="1280160"/>
-            <a:ext cx="9448495" cy="2011680"/>
+            <a:off x="1005840" y="1005840"/>
+            <a:ext cx="6583680" cy="4846320"/>
           </a:xfrm>
           <a:prstGeom prst="rect">
             <a:avLst/>
@@ -4825,8 +4798,8 @@
           </a:bodyPr>
           <a:lstStyle/>
           <a:p>
-            <a:pPr algn="ctr">
-              <a:defRPr sz="4000" b="1">
+            <a:pPr>
+              <a:defRPr sz="3800" b="1">
                 <a:solidFill>
                   <a:srgbClr val="00F2FE"/>
                 </a:solidFill>
@@ -4837,11 +4810,11 @@
             </a:r>
           </a:p>
           <a:p>
-            <a:pPr algn="ctr">
+            <a:pPr>
               <a:spcBef>
-                <a:spcPts val="1200"/>
+                <a:spcPts val="1000"/>
               </a:spcBef>
-              <a:defRPr sz="1600">
+              <a:defRPr sz="1500">
                 <a:solidFill>
                   <a:srgbClr val="FFFFFF"/>
                 </a:solidFill>
@@ -4852,76 +4825,60 @@
             </a:r>
           </a:p>
           <a:p>
-            <a:pPr algn="ctr">
+            <a:pPr>
+              <a:spcBef>
+                <a:spcPts val="1600"/>
+              </a:spcBef>
+              <a:defRPr sz="1200" b="1">
+                <a:solidFill>
+                  <a:srgbClr val="48CAE4"/>
+                </a:solidFill>
+              </a:defRPr>
+            </a:pPr>
+            <a:r>
+              <a:t>DEPARTMENT OF ARTIFICIAL INTELLIGENCE &amp; MACHINE LEARNING</a:t>
+            </a:r>
+          </a:p>
+          <a:p>
+            <a:pPr>
               <a:spcBef>
                 <a:spcPts val="1600"/>
               </a:spcBef>
               <a:defRPr sz="1300" b="1">
                 <a:solidFill>
-                  <a:srgbClr val="48CAE4"/>
+                  <a:srgbClr val="00F2FE"/>
                 </a:solidFill>
               </a:defRPr>
             </a:pPr>
             <a:r>
-              <a:t>DEPARTMENT OF ARTIFICIAL INTELLIGENCE &amp; MACHINE LEARNING</a:t>
-            </a:r>
-          </a:p>
-        </p:txBody>
-      </p:sp>
-      <p:sp>
-        <p:nvSpPr>
-          <p:cNvPr id="5" name="TextBox 4"/>
-          <p:cNvSpPr txBox="1"/>
-          <p:nvPr/>
-        </p:nvSpPr>
-        <p:spPr>
-          <a:xfrm>
-            <a:off x="1371600" y="3840480"/>
-            <a:ext cx="9448495" cy="1645920"/>
-          </a:xfrm>
-          <a:prstGeom prst="rect">
-            <a:avLst/>
-          </a:prstGeom>
-          <a:noFill/>
-        </p:spPr>
-        <p:txBody>
-          <a:bodyPr wrap="square">
-            <a:spAutoFit/>
-          </a:bodyPr>
-          <a:lstStyle/>
-          <a:p>
-            <a:pPr algn="ctr">
+              <a:t>Presented By:</a:t>
+            </a:r>
+          </a:p>
+          <a:p>
+            <a:pPr>
+              <a:spcBef>
+                <a:spcPts val="400"/>
+              </a:spcBef>
               <a:defRPr sz="1400" b="1">
                 <a:solidFill>
-                  <a:srgbClr val="00F2FE"/>
+                  <a:srgbClr val="FFFFFF"/>
                 </a:solidFill>
               </a:defRPr>
             </a:pPr>
             <a:r>
-              <a:t>Presented By:</a:t>
-            </a:r>
-          </a:p>
-          <a:p>
-            <a:pPr algn="ctr">
-              <a:spcBef>
-                <a:spcPts val="600"/>
-              </a:spcBef>
-              <a:defRPr sz="1500" b="1">
-                <a:solidFill>
-                  <a:srgbClr val="FFFFFF"/>
-                </a:solidFill>
-              </a:defRPr>
-            </a:pPr>
-            <a:r>
-              <a:t>BARATHKUMAR M (Reg. No: 111923AM01007)   |   SUBASH P (Reg. No: 111923AM02052)</a:t>
-            </a:r>
-          </a:p>
-          <a:p>
-            <a:pPr algn="ctr">
+              <a:t>BARATHKUMAR M (Reg. No: 111923AM01007)</a:t>
+            </a:r>
+            <a:br/>
+            <a:r>
+              <a:t>SUBASH P (Reg. No: 111923AM02052)</a:t>
+            </a:r>
+          </a:p>
+          <a:p>
+            <a:pPr>
               <a:spcBef>
                 <a:spcPts val="800"/>
               </a:spcBef>
-              <a:defRPr sz="1200">
+              <a:defRPr sz="1100">
                 <a:solidFill>
                   <a:srgbClr val="8D99AE"/>
                 </a:solidFill>
@@ -4933,6 +4890,30 @@
           </a:p>
         </p:txBody>
       </p:sp>
+      <p:pic>
+        <p:nvPicPr>
+          <p:cNvPr id="5" name="Picture 4" descr="security_shield.jpg"/>
+          <p:cNvPicPr>
+            <a:picLocks noChangeAspect="1"/>
+          </p:cNvPicPr>
+          <p:nvPr/>
+        </p:nvPicPr>
+        <p:blipFill>
+          <a:blip r:embed="rId1"/>
+          <a:stretch>
+            <a:fillRect/>
+          </a:stretch>
+        </p:blipFill>
+        <p:spPr>
+          <a:xfrm>
+            <a:off x="7772400" y="1188720"/>
+            <a:ext cx="3383280" cy="4480560"/>
+          </a:xfrm>
+          <a:prstGeom prst="rect">
+            <a:avLst/>
+          </a:prstGeom>
+        </p:spPr>
+      </p:pic>
     </p:spTree>
   </p:cSld>
   <p:clrMapOvr>
@@ -4942,7 +4923,7 @@
 </file>
 
 <file path=ppt/slides/slide10.xml><?xml version="1.0" encoding="utf-8"?>
-<p:sld xmlns:a="http://schemas.openxmlformats.org/drawingml/2006/main" xmlns:p="http://schemas.openxmlformats.org/presentationml/2006/main" xmlns:r="http://schemas.openxmlformats.org/officeDocument/2006/relationships">
+<p:sld xmlns:a="http://schemas.openxmlformats.org/drawingml/2006/main" xmlns:r="http://schemas.openxmlformats.org/officeDocument/2006/relationships" xmlns:p="http://schemas.openxmlformats.org/presentationml/2006/main">
   <p:cSld>
     <p:spTree>
       <p:nvGrpSpPr>
@@ -5021,7 +5002,7 @@
                 <a:solidFill>
                   <a:srgbClr val="00F2FE"/>
                 </a:solidFill>
-                <a:latin typeface="Calibri"/>
+                <a:latin typeface="Calibri" panose="020F0502020204030204"/>
               </a:defRPr>
             </a:pPr>
             <a:r>
@@ -5057,7 +5038,7 @@
                 <a:solidFill>
                   <a:srgbClr val="FFFFFF"/>
                 </a:solidFill>
-                <a:latin typeface="Calibri"/>
+                <a:latin typeface="Calibri" panose="020F0502020204030204"/>
               </a:defRPr>
             </a:pPr>
             <a:r>
@@ -5093,7 +5074,7 @@
                 <a:solidFill>
                   <a:srgbClr val="8D99AE"/>
                 </a:solidFill>
-                <a:latin typeface="Calibri"/>
+                <a:latin typeface="Calibri" panose="020F0502020204030204"/>
               </a:defRPr>
             </a:pPr>
             <a:r>
@@ -5133,7 +5114,7 @@
                     <a:lstStyle/>
                     <a:p>
                       <a:pPr>
-                        <a:defRPr b="1" sz="1400">
+                        <a:defRPr sz="1400" b="1">
                           <a:solidFill>
                             <a:srgbClr val="00F2FE"/>
                           </a:solidFill>
@@ -5156,7 +5137,7 @@
                     <a:lstStyle/>
                     <a:p>
                       <a:pPr>
-                        <a:defRPr b="1" sz="1400">
+                        <a:defRPr sz="1400" b="1">
                           <a:solidFill>
                             <a:srgbClr val="00F2FE"/>
                           </a:solidFill>
@@ -5179,7 +5160,7 @@
                     <a:lstStyle/>
                     <a:p>
                       <a:pPr>
-                        <a:defRPr b="1" sz="1400">
+                        <a:defRPr sz="1400" b="1">
                           <a:solidFill>
                             <a:srgbClr val="00F2FE"/>
                           </a:solidFill>
@@ -5202,7 +5183,7 @@
                     <a:lstStyle/>
                     <a:p>
                       <a:pPr>
-                        <a:defRPr b="1" sz="1400">
+                        <a:defRPr sz="1400" b="1">
                           <a:solidFill>
                             <a:srgbClr val="00F2FE"/>
                           </a:solidFill>
@@ -5703,7 +5684,7 @@
 </file>
 
 <file path=ppt/slides/slide11.xml><?xml version="1.0" encoding="utf-8"?>
-<p:sld xmlns:a="http://schemas.openxmlformats.org/drawingml/2006/main" xmlns:p="http://schemas.openxmlformats.org/presentationml/2006/main" xmlns:r="http://schemas.openxmlformats.org/officeDocument/2006/relationships">
+<p:sld xmlns:a="http://schemas.openxmlformats.org/drawingml/2006/main" xmlns:r="http://schemas.openxmlformats.org/officeDocument/2006/relationships" xmlns:p="http://schemas.openxmlformats.org/presentationml/2006/main">
   <p:cSld>
     <p:spTree>
       <p:nvGrpSpPr>
@@ -5782,7 +5763,7 @@
                 <a:solidFill>
                   <a:srgbClr val="00F2FE"/>
                 </a:solidFill>
-                <a:latin typeface="Calibri"/>
+                <a:latin typeface="Calibri" panose="020F0502020204030204"/>
               </a:defRPr>
             </a:pPr>
             <a:r>
@@ -5818,7 +5799,7 @@
                 <a:solidFill>
                   <a:srgbClr val="FFFFFF"/>
                 </a:solidFill>
-                <a:latin typeface="Calibri"/>
+                <a:latin typeface="Calibri" panose="020F0502020204030204"/>
               </a:defRPr>
             </a:pPr>
             <a:r>
@@ -5854,7 +5835,7 @@
                 <a:solidFill>
                   <a:srgbClr val="8D99AE"/>
                 </a:solidFill>
-                <a:latin typeface="Calibri"/>
+                <a:latin typeface="Calibri" panose="020F0502020204030204"/>
               </a:defRPr>
             </a:pPr>
             <a:r>
@@ -5872,7 +5853,7 @@
         <p:spPr>
           <a:xfrm>
             <a:off x="731520" y="1463040"/>
-            <a:ext cx="10698480" cy="804672"/>
+            <a:ext cx="7132320" cy="804672"/>
           </a:xfrm>
           <a:prstGeom prst="roundRect">
             <a:avLst/>
@@ -5916,8 +5897,8 @@
         </p:nvSpPr>
         <p:spPr>
           <a:xfrm>
-            <a:off x="1005840" y="1536192"/>
-            <a:ext cx="10149840" cy="658368"/>
+            <a:off x="914400" y="1536192"/>
+            <a:ext cx="6766560" cy="658368"/>
           </a:xfrm>
           <a:prstGeom prst="rect">
             <a:avLst/>
@@ -5931,7 +5912,7 @@
           <a:lstStyle/>
           <a:p>
             <a:r>
-              <a:rPr b="1" sz="1500">
+              <a:rPr sz="1400" b="1">
                 <a:solidFill>
                   <a:srgbClr val="00F2FE"/>
                 </a:solidFill>
@@ -5939,13 +5920,18 @@
               <a:t>🛡️ System Override Blocks: </a:t>
             </a:r>
             <a:r>
-              <a:rPr sz="1300">
+              <a:rPr sz="1250">
                 <a:solidFill>
                   <a:srgbClr val="FFFFFF"/>
                 </a:solidFill>
               </a:rPr>
-              <a:t>Detects prompts instructing the AI to 'Ignore all previous system rules' or change temperature settings.</a:t>
-            </a:r>
+              <a:t>Detects prompts instructing AI to 'Ignore previous rules'.</a:t>
+            </a:r>
+            <a:endParaRPr sz="1250">
+              <a:solidFill>
+                <a:srgbClr val="FFFFFF"/>
+              </a:solidFill>
+            </a:endParaRPr>
           </a:p>
         </p:txBody>
       </p:sp>
@@ -5958,7 +5944,7 @@
         <p:spPr>
           <a:xfrm>
             <a:off x="731520" y="2395728"/>
-            <a:ext cx="10698480" cy="804672"/>
+            <a:ext cx="7132320" cy="804672"/>
           </a:xfrm>
           <a:prstGeom prst="roundRect">
             <a:avLst/>
@@ -6002,8 +5988,8 @@
         </p:nvSpPr>
         <p:spPr>
           <a:xfrm>
-            <a:off x="1005840" y="2468880"/>
-            <a:ext cx="10149840" cy="658368"/>
+            <a:off x="914400" y="2468880"/>
+            <a:ext cx="6766560" cy="658368"/>
           </a:xfrm>
           <a:prstGeom prst="rect">
             <a:avLst/>
@@ -6017,7 +6003,7 @@
           <a:lstStyle/>
           <a:p>
             <a:r>
-              <a:rPr b="1" sz="1500">
+              <a:rPr sz="1400" b="1">
                 <a:solidFill>
                   <a:srgbClr val="00F2FE"/>
                 </a:solidFill>
@@ -6025,13 +6011,18 @@
               <a:t>🛡️ DAN Jailbreak Defense: </a:t>
             </a:r>
             <a:r>
-              <a:rPr sz="1300">
+              <a:rPr sz="1250">
                 <a:solidFill>
                   <a:srgbClr val="FFFFFF"/>
                 </a:solidFill>
               </a:rPr>
-              <a:t>Neutralizes Do-Anything-Now adversarial jailbreak prompts that try to bypass safety guardrails.</a:t>
-            </a:r>
+              <a:t>Neutralizes Do-Anything-Now jailbreak prompts.</a:t>
+            </a:r>
+            <a:endParaRPr sz="1250">
+              <a:solidFill>
+                <a:srgbClr val="FFFFFF"/>
+              </a:solidFill>
+            </a:endParaRPr>
           </a:p>
         </p:txBody>
       </p:sp>
@@ -6044,7 +6035,7 @@
         <p:spPr>
           <a:xfrm>
             <a:off x="731520" y="3328416"/>
-            <a:ext cx="10698480" cy="804672"/>
+            <a:ext cx="7132320" cy="804672"/>
           </a:xfrm>
           <a:prstGeom prst="roundRect">
             <a:avLst/>
@@ -6088,8 +6079,8 @@
         </p:nvSpPr>
         <p:spPr>
           <a:xfrm>
-            <a:off x="1005840" y="3401568"/>
-            <a:ext cx="10149840" cy="658368"/>
+            <a:off x="914400" y="3401568"/>
+            <a:ext cx="6766560" cy="658368"/>
           </a:xfrm>
           <a:prstGeom prst="rect">
             <a:avLst/>
@@ -6103,7 +6094,7 @@
           <a:lstStyle/>
           <a:p>
             <a:r>
-              <a:rPr b="1" sz="1500">
+              <a:rPr sz="1400" b="1">
                 <a:solidFill>
                   <a:srgbClr val="00F2FE"/>
                 </a:solidFill>
@@ -6111,13 +6102,18 @@
               <a:t>🛡️ Context Poisoning Defense: </a:t>
             </a:r>
             <a:r>
-              <a:rPr sz="1300">
+              <a:rPr sz="1250">
                 <a:solidFill>
                   <a:srgbClr val="FFFFFF"/>
                 </a:solidFill>
               </a:rPr>
-              <a:t>Prevents malicious instructions hidden inside retrieved RAG document chunks.</a:t>
-            </a:r>
+              <a:t>Prevents malicious instructions inside RAG document chunks.</a:t>
+            </a:r>
+            <a:endParaRPr sz="1250">
+              <a:solidFill>
+                <a:srgbClr val="FFFFFF"/>
+              </a:solidFill>
+            </a:endParaRPr>
           </a:p>
         </p:txBody>
       </p:sp>
@@ -6130,7 +6126,7 @@
         <p:spPr>
           <a:xfrm>
             <a:off x="731520" y="4261104"/>
-            <a:ext cx="10698480" cy="804672"/>
+            <a:ext cx="7132320" cy="804672"/>
           </a:xfrm>
           <a:prstGeom prst="roundRect">
             <a:avLst/>
@@ -6174,8 +6170,8 @@
         </p:nvSpPr>
         <p:spPr>
           <a:xfrm>
-            <a:off x="1005840" y="4334256"/>
-            <a:ext cx="10149840" cy="658368"/>
+            <a:off x="914400" y="4334256"/>
+            <a:ext cx="6766560" cy="658368"/>
           </a:xfrm>
           <a:prstGeom prst="rect">
             <a:avLst/>
@@ -6189,7 +6185,7 @@
           <a:lstStyle/>
           <a:p>
             <a:r>
-              <a:rPr b="1" sz="1500">
+              <a:rPr sz="1400" b="1">
                 <a:solidFill>
                   <a:srgbClr val="00F2FE"/>
                 </a:solidFill>
@@ -6197,13 +6193,18 @@
               <a:t>🛡️ Data Exfiltration Prevention: </a:t>
             </a:r>
             <a:r>
-              <a:rPr sz="1300">
+              <a:rPr sz="1250">
                 <a:solidFill>
                   <a:srgbClr val="FFFFFF"/>
                 </a:solidFill>
               </a:rPr>
-              <a:t>Blocks attempts asking the AI to reveal internal secrets, passwords, or system prompts.</a:t>
-            </a:r>
+              <a:t>Blocks prompts asking AI to reveal internal secret keys.</a:t>
+            </a:r>
+            <a:endParaRPr sz="1250">
+              <a:solidFill>
+                <a:srgbClr val="FFFFFF"/>
+              </a:solidFill>
+            </a:endParaRPr>
           </a:p>
         </p:txBody>
       </p:sp>
@@ -6216,7 +6217,7 @@
         <p:spPr>
           <a:xfrm>
             <a:off x="731520" y="5193792"/>
-            <a:ext cx="10698480" cy="804672"/>
+            <a:ext cx="7132320" cy="804672"/>
           </a:xfrm>
           <a:prstGeom prst="roundRect">
             <a:avLst/>
@@ -6260,8 +6261,8 @@
         </p:nvSpPr>
         <p:spPr>
           <a:xfrm>
-            <a:off x="1005840" y="5266944"/>
-            <a:ext cx="10149840" cy="658368"/>
+            <a:off x="914400" y="5266944"/>
+            <a:ext cx="6766560" cy="658368"/>
           </a:xfrm>
           <a:prstGeom prst="rect">
             <a:avLst/>
@@ -6275,7 +6276,7 @@
           <a:lstStyle/>
           <a:p>
             <a:r>
-              <a:rPr b="1" sz="1500">
+              <a:rPr sz="1400" b="1">
                 <a:solidFill>
                   <a:srgbClr val="00F2FE"/>
                 </a:solidFill>
@@ -6283,16 +6284,45 @@
               <a:t>🛡️ Automated Red Team Validated: </a:t>
             </a:r>
             <a:r>
-              <a:rPr sz="1300">
+              <a:rPr sz="1250">
                 <a:solidFill>
                   <a:srgbClr val="FFFFFF"/>
                 </a:solidFill>
               </a:rPr>
-              <a:t>Verified with 0% bypass rate under automated 1,000-payload cyber range attack campaigns.</a:t>
-            </a:r>
-          </a:p>
-        </p:txBody>
-      </p:sp>
+              <a:t>Verified 0% bypass rate under 1,000-payload campaigns.</a:t>
+            </a:r>
+            <a:endParaRPr sz="1250">
+              <a:solidFill>
+                <a:srgbClr val="FFFFFF"/>
+              </a:solidFill>
+            </a:endParaRPr>
+          </a:p>
+        </p:txBody>
+      </p:sp>
+      <p:pic>
+        <p:nvPicPr>
+          <p:cNvPr id="16" name="Picture 15" descr="threat_nodes.jpg"/>
+          <p:cNvPicPr>
+            <a:picLocks noChangeAspect="1"/>
+          </p:cNvPicPr>
+          <p:nvPr/>
+        </p:nvPicPr>
+        <p:blipFill>
+          <a:blip r:embed="rId1"/>
+          <a:stretch>
+            <a:fillRect/>
+          </a:stretch>
+        </p:blipFill>
+        <p:spPr>
+          <a:xfrm>
+            <a:off x="8138160" y="1463040"/>
+            <a:ext cx="3291840" cy="4572000"/>
+          </a:xfrm>
+          <a:prstGeom prst="rect">
+            <a:avLst/>
+          </a:prstGeom>
+        </p:spPr>
+      </p:pic>
     </p:spTree>
   </p:cSld>
   <p:clrMapOvr>
@@ -6302,7 +6332,7 @@
 </file>
 
 <file path=ppt/slides/slide12.xml><?xml version="1.0" encoding="utf-8"?>
-<p:sld xmlns:a="http://schemas.openxmlformats.org/drawingml/2006/main" xmlns:p="http://schemas.openxmlformats.org/presentationml/2006/main" xmlns:r="http://schemas.openxmlformats.org/officeDocument/2006/relationships">
+<p:sld xmlns:a="http://schemas.openxmlformats.org/drawingml/2006/main" xmlns:r="http://schemas.openxmlformats.org/officeDocument/2006/relationships" xmlns:p="http://schemas.openxmlformats.org/presentationml/2006/main">
   <p:cSld>
     <p:spTree>
       <p:nvGrpSpPr>
@@ -6381,7 +6411,7 @@
                 <a:solidFill>
                   <a:srgbClr val="00F2FE"/>
                 </a:solidFill>
-                <a:latin typeface="Calibri"/>
+                <a:latin typeface="Calibri" panose="020F0502020204030204"/>
               </a:defRPr>
             </a:pPr>
             <a:r>
@@ -6417,7 +6447,7 @@
                 <a:solidFill>
                   <a:srgbClr val="FFFFFF"/>
                 </a:solidFill>
-                <a:latin typeface="Calibri"/>
+                <a:latin typeface="Calibri" panose="020F0502020204030204"/>
               </a:defRPr>
             </a:pPr>
             <a:r>
@@ -6453,7 +6483,7 @@
                 <a:solidFill>
                   <a:srgbClr val="8D99AE"/>
                 </a:solidFill>
-                <a:latin typeface="Calibri"/>
+                <a:latin typeface="Calibri" panose="020F0502020204030204"/>
               </a:defRPr>
             </a:pPr>
             <a:r>
@@ -7010,7 +7040,7 @@
 </file>
 
 <file path=ppt/slides/slide13.xml><?xml version="1.0" encoding="utf-8"?>
-<p:sld xmlns:a="http://schemas.openxmlformats.org/drawingml/2006/main" xmlns:p="http://schemas.openxmlformats.org/presentationml/2006/main" xmlns:r="http://schemas.openxmlformats.org/officeDocument/2006/relationships">
+<p:sld xmlns:a="http://schemas.openxmlformats.org/drawingml/2006/main" xmlns:r="http://schemas.openxmlformats.org/officeDocument/2006/relationships" xmlns:p="http://schemas.openxmlformats.org/presentationml/2006/main">
   <p:cSld>
     <p:spTree>
       <p:nvGrpSpPr>
@@ -7089,7 +7119,7 @@
                 <a:solidFill>
                   <a:srgbClr val="00F2FE"/>
                 </a:solidFill>
-                <a:latin typeface="Calibri"/>
+                <a:latin typeface="Calibri" panose="020F0502020204030204"/>
               </a:defRPr>
             </a:pPr>
             <a:r>
@@ -7125,7 +7155,7 @@
                 <a:solidFill>
                   <a:srgbClr val="FFFFFF"/>
                 </a:solidFill>
-                <a:latin typeface="Calibri"/>
+                <a:latin typeface="Calibri" panose="020F0502020204030204"/>
               </a:defRPr>
             </a:pPr>
             <a:r>
@@ -7161,7 +7191,7 @@
                 <a:solidFill>
                   <a:srgbClr val="8D99AE"/>
                 </a:solidFill>
-                <a:latin typeface="Calibri"/>
+                <a:latin typeface="Calibri" panose="020F0502020204030204"/>
               </a:defRPr>
             </a:pPr>
             <a:r>
@@ -7839,7 +7869,7 @@
 </file>
 
 <file path=ppt/slides/slide14.xml><?xml version="1.0" encoding="utf-8"?>
-<p:sld xmlns:a="http://schemas.openxmlformats.org/drawingml/2006/main" xmlns:p="http://schemas.openxmlformats.org/presentationml/2006/main" xmlns:r="http://schemas.openxmlformats.org/officeDocument/2006/relationships">
+<p:sld xmlns:a="http://schemas.openxmlformats.org/drawingml/2006/main" xmlns:r="http://schemas.openxmlformats.org/officeDocument/2006/relationships" xmlns:p="http://schemas.openxmlformats.org/presentationml/2006/main">
   <p:cSld>
     <p:spTree>
       <p:nvGrpSpPr>
@@ -7918,7 +7948,7 @@
                 <a:solidFill>
                   <a:srgbClr val="00F2FE"/>
                 </a:solidFill>
-                <a:latin typeface="Calibri"/>
+                <a:latin typeface="Calibri" panose="020F0502020204030204"/>
               </a:defRPr>
             </a:pPr>
             <a:r>
@@ -7954,7 +7984,7 @@
                 <a:solidFill>
                   <a:srgbClr val="FFFFFF"/>
                 </a:solidFill>
-                <a:latin typeface="Calibri"/>
+                <a:latin typeface="Calibri" panose="020F0502020204030204"/>
               </a:defRPr>
             </a:pPr>
             <a:r>
@@ -7990,7 +8020,7 @@
                 <a:solidFill>
                   <a:srgbClr val="8D99AE"/>
                 </a:solidFill>
-                <a:latin typeface="Calibri"/>
+                <a:latin typeface="Calibri" panose="020F0502020204030204"/>
               </a:defRPr>
             </a:pPr>
             <a:r>
@@ -8007,8 +8037,8 @@
         </p:nvSpPr>
         <p:spPr>
           <a:xfrm>
-            <a:off x="731520" y="1828800"/>
-            <a:ext cx="2514600" cy="2926080"/>
+            <a:off x="731520" y="1463040"/>
+            <a:ext cx="2514600" cy="2103120"/>
           </a:xfrm>
           <a:prstGeom prst="roundRect">
             <a:avLst/>
@@ -8052,8 +8082,8 @@
         </p:nvSpPr>
         <p:spPr>
           <a:xfrm>
-            <a:off x="822960" y="1965960"/>
-            <a:ext cx="2331720" cy="2651760"/>
+            <a:off x="822960" y="1572768"/>
+            <a:ext cx="2331720" cy="1828800"/>
           </a:xfrm>
           <a:prstGeom prst="rect">
             <a:avLst/>
@@ -8067,7 +8097,7 @@
           <a:lstStyle/>
           <a:p>
             <a:pPr algn="ctr">
-              <a:defRPr sz="1500" b="1">
+              <a:defRPr sz="1400" b="1">
                 <a:solidFill>
                   <a:srgbClr val="00F2FE"/>
                 </a:solidFill>
@@ -8080,16 +8110,16 @@
           <a:p>
             <a:pPr algn="ctr">
               <a:spcBef>
-                <a:spcPts val="1400"/>
+                <a:spcPts val="1000"/>
               </a:spcBef>
-              <a:defRPr sz="1300">
+              <a:defRPr sz="1150">
                 <a:solidFill>
                   <a:srgbClr val="FFFFFF"/>
                 </a:solidFill>
               </a:defRPr>
             </a:pPr>
             <a:r>
-              <a:t>User types or selects a prompt in the interactive Prompt Sandbox.</a:t>
+              <a:t>User types prompt in Prompt Sandbox.</a:t>
             </a:r>
           </a:p>
         </p:txBody>
@@ -8102,7 +8132,7 @@
         </p:nvSpPr>
         <p:spPr>
           <a:xfrm>
-            <a:off x="3264408" y="3108960"/>
+            <a:off x="3264408" y="2377440"/>
             <a:ext cx="182880" cy="320040"/>
           </a:xfrm>
           <a:prstGeom prst="rightArrow">
@@ -8145,8 +8175,8 @@
         </p:nvSpPr>
         <p:spPr>
           <a:xfrm>
-            <a:off x="3456432" y="1828800"/>
-            <a:ext cx="2514600" cy="2926080"/>
+            <a:off x="3456432" y="1463040"/>
+            <a:ext cx="2514600" cy="2103120"/>
           </a:xfrm>
           <a:prstGeom prst="roundRect">
             <a:avLst/>
@@ -8190,8 +8220,8 @@
         </p:nvSpPr>
         <p:spPr>
           <a:xfrm>
-            <a:off x="3547872" y="1965960"/>
-            <a:ext cx="2331720" cy="2651760"/>
+            <a:off x="3547872" y="1572768"/>
+            <a:ext cx="2331720" cy="1828800"/>
           </a:xfrm>
           <a:prstGeom prst="rect">
             <a:avLst/>
@@ -8205,7 +8235,7 @@
           <a:lstStyle/>
           <a:p>
             <a:pPr algn="ctr">
-              <a:defRPr sz="1500" b="1">
+              <a:defRPr sz="1400" b="1">
                 <a:solidFill>
                   <a:srgbClr val="00F2FE"/>
                 </a:solidFill>
@@ -8218,16 +8248,16 @@
           <a:p>
             <a:pPr algn="ctr">
               <a:spcBef>
-                <a:spcPts val="1400"/>
+                <a:spcPts val="1000"/>
               </a:spcBef>
-              <a:defRPr sz="1300">
+              <a:defRPr sz="1150">
                 <a:solidFill>
                   <a:srgbClr val="FFFFFF"/>
                 </a:solidFill>
               </a:defRPr>
             </a:pPr>
             <a:r>
-              <a:t>High-speed Regex scans identity tags + Transformer NER extracts context spans.</a:t>
+              <a:t>High-speed Regex + Transformer NER spans.</a:t>
             </a:r>
           </a:p>
         </p:txBody>
@@ -8240,7 +8270,7 @@
         </p:nvSpPr>
         <p:spPr>
           <a:xfrm>
-            <a:off x="5989320" y="3108960"/>
+            <a:off x="5989320" y="2377440"/>
             <a:ext cx="182880" cy="320040"/>
           </a:xfrm>
           <a:prstGeom prst="rightArrow">
@@ -8283,8 +8313,8 @@
         </p:nvSpPr>
         <p:spPr>
           <a:xfrm>
-            <a:off x="6181344" y="1828800"/>
-            <a:ext cx="2514600" cy="2926080"/>
+            <a:off x="6181344" y="1463040"/>
+            <a:ext cx="2514600" cy="2103120"/>
           </a:xfrm>
           <a:prstGeom prst="roundRect">
             <a:avLst/>
@@ -8328,8 +8358,8 @@
         </p:nvSpPr>
         <p:spPr>
           <a:xfrm>
-            <a:off x="6272784" y="1965960"/>
-            <a:ext cx="2331720" cy="2651760"/>
+            <a:off x="6272784" y="1572768"/>
+            <a:ext cx="2331720" cy="1828800"/>
           </a:xfrm>
           <a:prstGeom prst="rect">
             <a:avLst/>
@@ -8343,7 +8373,7 @@
           <a:lstStyle/>
           <a:p>
             <a:pPr algn="ctr">
-              <a:defRPr sz="1500" b="1">
+              <a:defRPr sz="1400" b="1">
                 <a:solidFill>
                   <a:srgbClr val="00F2FE"/>
                 </a:solidFill>
@@ -8356,16 +8386,16 @@
           <a:p>
             <a:pPr algn="ctr">
               <a:spcBef>
-                <a:spcPts val="1400"/>
+                <a:spcPts val="1000"/>
               </a:spcBef>
-              <a:defRPr sz="1300">
+              <a:defRPr sz="1150">
                 <a:solidFill>
                   <a:srgbClr val="FFFFFF"/>
                 </a:solidFill>
               </a:defRPr>
             </a:pPr>
             <a:r>
-              <a:t>Sensitive spans masked (e.g. Aadhaar) &amp; Risk score (0-100%) calculated.</a:t>
+              <a:t>Partial Masking (Aadhaar) &amp; Risk score.</a:t>
             </a:r>
           </a:p>
         </p:txBody>
@@ -8378,7 +8408,7 @@
         </p:nvSpPr>
         <p:spPr>
           <a:xfrm>
-            <a:off x="8714232" y="3108960"/>
+            <a:off x="8714232" y="2377440"/>
             <a:ext cx="182880" cy="320040"/>
           </a:xfrm>
           <a:prstGeom prst="rightArrow">
@@ -8421,8 +8451,8 @@
         </p:nvSpPr>
         <p:spPr>
           <a:xfrm>
-            <a:off x="8906256" y="1828800"/>
-            <a:ext cx="2514600" cy="2926080"/>
+            <a:off x="8906256" y="1463040"/>
+            <a:ext cx="2514600" cy="2103120"/>
           </a:xfrm>
           <a:prstGeom prst="roundRect">
             <a:avLst/>
@@ -8466,8 +8496,8 @@
         </p:nvSpPr>
         <p:spPr>
           <a:xfrm>
-            <a:off x="8997696" y="1965960"/>
-            <a:ext cx="2331720" cy="2651760"/>
+            <a:off x="8997696" y="1572768"/>
+            <a:ext cx="2331720" cy="1828800"/>
           </a:xfrm>
           <a:prstGeom prst="rect">
             <a:avLst/>
@@ -8481,7 +8511,7 @@
           <a:lstStyle/>
           <a:p>
             <a:pPr algn="ctr">
-              <a:defRPr sz="1500" b="1">
+              <a:defRPr sz="1400" b="1">
                 <a:solidFill>
                   <a:srgbClr val="00F2FE"/>
                 </a:solidFill>
@@ -8494,74 +8524,44 @@
           <a:p>
             <a:pPr algn="ctr">
               <a:spcBef>
-                <a:spcPts val="1400"/>
+                <a:spcPts val="1000"/>
               </a:spcBef>
-              <a:defRPr sz="1300">
+              <a:defRPr sz="1150">
                 <a:solidFill>
                   <a:srgbClr val="FFFFFF"/>
                 </a:solidFill>
               </a:defRPr>
             </a:pPr>
             <a:r>
-              <a:t>Sanitized prompt sent to LLM + Event saved to Cryptographic Audit Ledger.</a:t>
-            </a:r>
-          </a:p>
-        </p:txBody>
-      </p:sp>
-      <p:sp>
-        <p:nvSpPr>
-          <p:cNvPr id="17" name="Rounded Rectangle 16"/>
-          <p:cNvSpPr/>
-          <p:nvPr/>
-        </p:nvSpPr>
-        <p:spPr>
-          <a:xfrm>
-            <a:off x="731520" y="5029200"/>
-            <a:ext cx="10698480" cy="1005840"/>
-          </a:xfrm>
-          <a:prstGeom prst="roundRect">
-            <a:avLst/>
-          </a:prstGeom>
-          <a:solidFill>
-            <a:srgbClr val="1C2541"/>
-          </a:solidFill>
-          <a:ln w="12700">
-            <a:solidFill>
-              <a:srgbClr val="48CAE4"/>
-            </a:solidFill>
-          </a:ln>
-        </p:spPr>
-        <p:style>
-          <a:lnRef idx="1">
-            <a:schemeClr val="accent1"/>
-          </a:lnRef>
-          <a:fillRef idx="3">
-            <a:schemeClr val="accent1"/>
-          </a:fillRef>
-          <a:effectRef idx="2">
-            <a:schemeClr val="accent1"/>
-          </a:effectRef>
-          <a:fontRef idx="minor">
-            <a:schemeClr val="lt1"/>
-          </a:fontRef>
-        </p:style>
-        <p:txBody>
-          <a:bodyPr rtlCol="0" anchor="ctr" wrap="square"/>
-          <a:lstStyle/>
-          <a:p>
-            <a:pPr algn="ctr">
-              <a:defRPr sz="1400" b="1">
-                <a:solidFill>
-                  <a:srgbClr val="39FF14"/>
-                </a:solidFill>
-              </a:defRPr>
-            </a:pPr>
-            <a:r>
-              <a:t>⚡ End-to-End Processing Time: &lt; 50ms per prompt request with 100% data confidentiality.</a:t>
-            </a:r>
-          </a:p>
-        </p:txBody>
-      </p:sp>
+              <a:t>Sanitized text sent to LLM + SHA-256 Log.</a:t>
+            </a:r>
+          </a:p>
+        </p:txBody>
+      </p:sp>
+      <p:pic>
+        <p:nvPicPr>
+          <p:cNvPr id="17" name="Picture 16" descr="threat_nodes.jpg"/>
+          <p:cNvPicPr>
+            <a:picLocks noChangeAspect="1"/>
+          </p:cNvPicPr>
+          <p:nvPr/>
+        </p:nvPicPr>
+        <p:blipFill>
+          <a:blip r:embed="rId1"/>
+          <a:stretch>
+            <a:fillRect/>
+          </a:stretch>
+        </p:blipFill>
+        <p:spPr>
+          <a:xfrm>
+            <a:off x="731520" y="3840480"/>
+            <a:ext cx="10698480" cy="2286000"/>
+          </a:xfrm>
+          <a:prstGeom prst="rect">
+            <a:avLst/>
+          </a:prstGeom>
+        </p:spPr>
+      </p:pic>
     </p:spTree>
   </p:cSld>
   <p:clrMapOvr>
@@ -8571,7 +8571,7 @@
 </file>
 
 <file path=ppt/slides/slide15.xml><?xml version="1.0" encoding="utf-8"?>
-<p:sld xmlns:a="http://schemas.openxmlformats.org/drawingml/2006/main" xmlns:p="http://schemas.openxmlformats.org/presentationml/2006/main" xmlns:r="http://schemas.openxmlformats.org/officeDocument/2006/relationships">
+<p:sld xmlns:a="http://schemas.openxmlformats.org/drawingml/2006/main" xmlns:r="http://schemas.openxmlformats.org/officeDocument/2006/relationships" xmlns:p="http://schemas.openxmlformats.org/presentationml/2006/main">
   <p:cSld>
     <p:spTree>
       <p:nvGrpSpPr>
@@ -8650,7 +8650,7 @@
                 <a:solidFill>
                   <a:srgbClr val="00F2FE"/>
                 </a:solidFill>
-                <a:latin typeface="Calibri"/>
+                <a:latin typeface="Calibri" panose="020F0502020204030204"/>
               </a:defRPr>
             </a:pPr>
             <a:r>
@@ -8686,7 +8686,7 @@
                 <a:solidFill>
                   <a:srgbClr val="FFFFFF"/>
                 </a:solidFill>
-                <a:latin typeface="Calibri"/>
+                <a:latin typeface="Calibri" panose="020F0502020204030204"/>
               </a:defRPr>
             </a:pPr>
             <a:r>
@@ -8722,7 +8722,7 @@
                 <a:solidFill>
                   <a:srgbClr val="8D99AE"/>
                 </a:solidFill>
-                <a:latin typeface="Calibri"/>
+                <a:latin typeface="Calibri" panose="020F0502020204030204"/>
               </a:defRPr>
             </a:pPr>
             <a:r>
@@ -8799,7 +8799,7 @@
           <a:lstStyle/>
           <a:p>
             <a:r>
-              <a:rPr b="1" sz="1500">
+              <a:rPr sz="1500" b="1">
                 <a:solidFill>
                   <a:srgbClr val="39FF14"/>
                 </a:solidFill>
@@ -8814,6 +8814,11 @@
               </a:rPr>
               <a:t>Prevents accidental leakage of confidential Indian identity tags and financial data.</a:t>
             </a:r>
+            <a:endParaRPr sz="1400">
+              <a:solidFill>
+                <a:srgbClr val="FFFFFF"/>
+              </a:solidFill>
+            </a:endParaRPr>
           </a:p>
         </p:txBody>
       </p:sp>
@@ -8885,7 +8890,7 @@
           <a:lstStyle/>
           <a:p>
             <a:r>
-              <a:rPr b="1" sz="1500">
+              <a:rPr sz="1500" b="1">
                 <a:solidFill>
                   <a:srgbClr val="39FF14"/>
                 </a:solidFill>
@@ -8900,6 +8905,11 @@
               </a:rPr>
               <a:t>Keeps AI responses accurate without ruining sentence structure or meaning.</a:t>
             </a:r>
+            <a:endParaRPr sz="1400">
+              <a:solidFill>
+                <a:srgbClr val="FFFFFF"/>
+              </a:solidFill>
+            </a:endParaRPr>
           </a:p>
         </p:txBody>
       </p:sp>
@@ -8971,7 +8981,7 @@
           <a:lstStyle/>
           <a:p>
             <a:r>
-              <a:rPr b="1" sz="1500">
+              <a:rPr sz="1500" b="1">
                 <a:solidFill>
                   <a:srgbClr val="39FF14"/>
                 </a:solidFill>
@@ -8986,6 +8996,11 @@
               </a:rPr>
               <a:t>Executes full multi-stage detection in under 50ms with zero noticeable delay.</a:t>
             </a:r>
+            <a:endParaRPr sz="1400">
+              <a:solidFill>
+                <a:srgbClr val="FFFFFF"/>
+              </a:solidFill>
+            </a:endParaRPr>
           </a:p>
         </p:txBody>
       </p:sp>
@@ -9057,7 +9072,7 @@
           <a:lstStyle/>
           <a:p>
             <a:r>
-              <a:rPr b="1" sz="1500">
+              <a:rPr sz="1500" b="1">
                 <a:solidFill>
                   <a:srgbClr val="39FF14"/>
                 </a:solidFill>
@@ -9072,6 +9087,11 @@
               </a:rPr>
               <a:t>Supports GDPR, HIPAA, and DPDP Act 2023 data protection standards.</a:t>
             </a:r>
+            <a:endParaRPr sz="1400">
+              <a:solidFill>
+                <a:srgbClr val="FFFFFF"/>
+              </a:solidFill>
+            </a:endParaRPr>
           </a:p>
         </p:txBody>
       </p:sp>
@@ -9143,7 +9163,7 @@
           <a:lstStyle/>
           <a:p>
             <a:r>
-              <a:rPr b="1" sz="1500">
+              <a:rPr sz="1500" b="1">
                 <a:solidFill>
                   <a:srgbClr val="39FF14"/>
                 </a:solidFill>
@@ -9158,6 +9178,11 @@
               </a:rPr>
               <a:t>Includes live threat charts, Red Team cyber range simulator, and Security Copilot assistant.</a:t>
             </a:r>
+            <a:endParaRPr sz="1400">
+              <a:solidFill>
+                <a:srgbClr val="FFFFFF"/>
+              </a:solidFill>
+            </a:endParaRPr>
           </a:p>
         </p:txBody>
       </p:sp>
@@ -9170,7 +9195,7 @@
 </file>
 
 <file path=ppt/slides/slide16.xml><?xml version="1.0" encoding="utf-8"?>
-<p:sld xmlns:a="http://schemas.openxmlformats.org/drawingml/2006/main" xmlns:p="http://schemas.openxmlformats.org/presentationml/2006/main" xmlns:r="http://schemas.openxmlformats.org/officeDocument/2006/relationships">
+<p:sld xmlns:a="http://schemas.openxmlformats.org/drawingml/2006/main" xmlns:r="http://schemas.openxmlformats.org/officeDocument/2006/relationships" xmlns:p="http://schemas.openxmlformats.org/presentationml/2006/main">
   <p:cSld>
     <p:spTree>
       <p:nvGrpSpPr>
@@ -9249,7 +9274,7 @@
                 <a:solidFill>
                   <a:srgbClr val="00F2FE"/>
                 </a:solidFill>
-                <a:latin typeface="Calibri"/>
+                <a:latin typeface="Calibri" panose="020F0502020204030204"/>
               </a:defRPr>
             </a:pPr>
             <a:r>
@@ -9285,7 +9310,7 @@
                 <a:solidFill>
                   <a:srgbClr val="FFFFFF"/>
                 </a:solidFill>
-                <a:latin typeface="Calibri"/>
+                <a:latin typeface="Calibri" panose="020F0502020204030204"/>
               </a:defRPr>
             </a:pPr>
             <a:r>
@@ -9321,7 +9346,7 @@
                 <a:solidFill>
                   <a:srgbClr val="8D99AE"/>
                 </a:solidFill>
-                <a:latin typeface="Calibri"/>
+                <a:latin typeface="Calibri" panose="020F0502020204030204"/>
               </a:defRPr>
             </a:pPr>
             <a:r>
@@ -9398,7 +9423,7 @@
           <a:lstStyle/>
           <a:p>
             <a:r>
-              <a:rPr b="1" sz="1500">
+              <a:rPr sz="1500" b="1">
                 <a:solidFill>
                   <a:srgbClr val="00F2FE"/>
                 </a:solidFill>
@@ -9413,6 +9438,11 @@
               </a:rPr>
               <a:t> Add real-time image OCR and audio scanning for multimodal LLM inputs.</a:t>
             </a:r>
+            <a:endParaRPr sz="1400">
+              <a:solidFill>
+                <a:srgbClr val="FFFFFF"/>
+              </a:solidFill>
+            </a:endParaRPr>
           </a:p>
         </p:txBody>
       </p:sp>
@@ -9484,7 +9514,7 @@
           <a:lstStyle/>
           <a:p>
             <a:r>
-              <a:rPr b="1" sz="1500">
+              <a:rPr sz="1500" b="1">
                 <a:solidFill>
                   <a:srgbClr val="00F2FE"/>
                 </a:solidFill>
@@ -9499,6 +9529,11 @@
               </a:rPr>
               <a:t> Develop Chrome / Edge extension to auto-sanitize ChatGPT &amp; Claude web UI.</a:t>
             </a:r>
+            <a:endParaRPr sz="1400">
+              <a:solidFill>
+                <a:srgbClr val="FFFFFF"/>
+              </a:solidFill>
+            </a:endParaRPr>
           </a:p>
         </p:txBody>
       </p:sp>
@@ -9570,7 +9605,7 @@
           <a:lstStyle/>
           <a:p>
             <a:r>
-              <a:rPr b="1" sz="1500">
+              <a:rPr sz="1500" b="1">
                 <a:solidFill>
                   <a:srgbClr val="00F2FE"/>
                 </a:solidFill>
@@ -9585,6 +9620,11 @@
               </a:rPr>
               <a:t> Expand zero-knowledge encrypted computation for cloud LLM servers.</a:t>
             </a:r>
+            <a:endParaRPr sz="1400">
+              <a:solidFill>
+                <a:srgbClr val="FFFFFF"/>
+              </a:solidFill>
+            </a:endParaRPr>
           </a:p>
         </p:txBody>
       </p:sp>
@@ -9656,7 +9696,7 @@
           <a:lstStyle/>
           <a:p>
             <a:r>
-              <a:rPr b="1" sz="1500">
+              <a:rPr sz="1500" b="1">
                 <a:solidFill>
                   <a:srgbClr val="00F2FE"/>
                 </a:solidFill>
@@ -9671,6 +9711,11 @@
               </a:rPr>
               <a:t> Integrate hardware key storage for enterprise-grade server deployment.</a:t>
             </a:r>
+            <a:endParaRPr sz="1400">
+              <a:solidFill>
+                <a:srgbClr val="FFFFFF"/>
+              </a:solidFill>
+            </a:endParaRPr>
           </a:p>
         </p:txBody>
       </p:sp>
@@ -9742,7 +9787,7 @@
           <a:lstStyle/>
           <a:p>
             <a:r>
-              <a:rPr b="1" sz="1500">
+              <a:rPr sz="1500" b="1">
                 <a:solidFill>
                   <a:srgbClr val="00F2FE"/>
                 </a:solidFill>
@@ -9757,6 +9802,11 @@
               </a:rPr>
               <a:t> Add one-click PDF / CSV audit report generator for compliance officers.</a:t>
             </a:r>
+            <a:endParaRPr sz="1400">
+              <a:solidFill>
+                <a:srgbClr val="FFFFFF"/>
+              </a:solidFill>
+            </a:endParaRPr>
           </a:p>
         </p:txBody>
       </p:sp>
@@ -9769,7 +9819,7 @@
 </file>
 
 <file path=ppt/slides/slide17.xml><?xml version="1.0" encoding="utf-8"?>
-<p:sld xmlns:a="http://schemas.openxmlformats.org/drawingml/2006/main" xmlns:p="http://schemas.openxmlformats.org/presentationml/2006/main" xmlns:r="http://schemas.openxmlformats.org/officeDocument/2006/relationships">
+<p:sld xmlns:a="http://schemas.openxmlformats.org/drawingml/2006/main" xmlns:r="http://schemas.openxmlformats.org/officeDocument/2006/relationships" xmlns:p="http://schemas.openxmlformats.org/presentationml/2006/main">
   <p:cSld>
     <p:spTree>
       <p:nvGrpSpPr>
@@ -9848,7 +9898,7 @@
                 <a:solidFill>
                   <a:srgbClr val="00F2FE"/>
                 </a:solidFill>
-                <a:latin typeface="Calibri"/>
+                <a:latin typeface="Calibri" panose="020F0502020204030204"/>
               </a:defRPr>
             </a:pPr>
             <a:r>
@@ -9884,7 +9934,7 @@
                 <a:solidFill>
                   <a:srgbClr val="FFFFFF"/>
                 </a:solidFill>
-                <a:latin typeface="Calibri"/>
+                <a:latin typeface="Calibri" panose="020F0502020204030204"/>
               </a:defRPr>
             </a:pPr>
             <a:r>
@@ -9920,7 +9970,7 @@
                 <a:solidFill>
                   <a:srgbClr val="8D99AE"/>
                 </a:solidFill>
-                <a:latin typeface="Calibri"/>
+                <a:latin typeface="Calibri" panose="020F0502020204030204"/>
               </a:defRPr>
             </a:pPr>
             <a:r>
@@ -10004,6 +10054,11 @@
               </a:rPr>
               <a:t>📌 SecureLLM Shield successfully solves the critical problem of privacy leakage in Large Language Models.</a:t>
             </a:r>
+            <a:endParaRPr sz="1400">
+              <a:solidFill>
+                <a:srgbClr val="FFFFFF"/>
+              </a:solidFill>
+            </a:endParaRPr>
           </a:p>
         </p:txBody>
       </p:sp>
@@ -10082,6 +10137,11 @@
               </a:rPr>
               <a:t>📌 Combines 20-entity PII detection, context-preserving partial masking, and prompt injection defense.</a:t>
             </a:r>
+            <a:endParaRPr sz="1400">
+              <a:solidFill>
+                <a:srgbClr val="FFFFFF"/>
+              </a:solidFill>
+            </a:endParaRPr>
           </a:p>
         </p:txBody>
       </p:sp>
@@ -10160,6 +10220,11 @@
               </a:rPr>
               <a:t>📌 Provides enterprise-grade audit logging with SHA-256 cryptographic chain verification.</a:t>
             </a:r>
+            <a:endParaRPr sz="1400">
+              <a:solidFill>
+                <a:srgbClr val="FFFFFF"/>
+              </a:solidFill>
+            </a:endParaRPr>
           </a:p>
         </p:txBody>
       </p:sp>
@@ -10238,6 +10303,11 @@
               </a:rPr>
               <a:t>📌 Proven 0% bypass rate under automated 1,000-payload Red Team cyber range attack campaigns.</a:t>
             </a:r>
+            <a:endParaRPr sz="1400">
+              <a:solidFill>
+                <a:srgbClr val="FFFFFF"/>
+              </a:solidFill>
+            </a:endParaRPr>
           </a:p>
         </p:txBody>
       </p:sp>
@@ -10316,6 +10386,11 @@
               </a:rPr>
               <a:t>📌 Offers a scalable, ultra-fast security gateway for safe enterprise AI deployment.</a:t>
             </a:r>
+            <a:endParaRPr sz="1400">
+              <a:solidFill>
+                <a:srgbClr val="FFFFFF"/>
+              </a:solidFill>
+            </a:endParaRPr>
           </a:p>
         </p:txBody>
       </p:sp>
@@ -10328,7 +10403,7 @@
 </file>
 
 <file path=ppt/slides/slide18.xml><?xml version="1.0" encoding="utf-8"?>
-<p:sld xmlns:a="http://schemas.openxmlformats.org/drawingml/2006/main" xmlns:p="http://schemas.openxmlformats.org/presentationml/2006/main" xmlns:r="http://schemas.openxmlformats.org/officeDocument/2006/relationships">
+<p:sld xmlns:a="http://schemas.openxmlformats.org/drawingml/2006/main" xmlns:r="http://schemas.openxmlformats.org/officeDocument/2006/relationships" xmlns:p="http://schemas.openxmlformats.org/presentationml/2006/main">
   <p:cSld>
     <p:spTree>
       <p:nvGrpSpPr>
@@ -10345,7 +10420,7 @@
         </p:nvSpPr>
         <p:spPr>
           <a:xfrm>
-            <a:off x="0" y="0"/>
+            <a:off x="-172720" y="0"/>
             <a:ext cx="12191695" cy="6858000"/>
           </a:xfrm>
           <a:prstGeom prst="rect">
@@ -10388,8 +10463,8 @@
         </p:nvSpPr>
         <p:spPr>
           <a:xfrm>
-            <a:off x="914400" y="914400"/>
-            <a:ext cx="10362895" cy="5029200"/>
+            <a:off x="731520" y="731520"/>
+            <a:ext cx="10728655" cy="5394960"/>
           </a:xfrm>
           <a:prstGeom prst="roundRect">
             <a:avLst/>
@@ -10433,8 +10508,8 @@
         </p:nvSpPr>
         <p:spPr>
           <a:xfrm>
-            <a:off x="1371600" y="1463040"/>
-            <a:ext cx="9448495" cy="3931920"/>
+            <a:off x="1005840" y="1280160"/>
+            <a:ext cx="6583680" cy="4389120"/>
           </a:xfrm>
           <a:prstGeom prst="rect">
             <a:avLst/>
@@ -10447,7 +10522,7 @@
           </a:bodyPr>
           <a:lstStyle/>
           <a:p>
-            <a:pPr algn="ctr">
+            <a:pPr>
               <a:defRPr sz="4400" b="1">
                 <a:solidFill>
                   <a:srgbClr val="00F2FE"/>
@@ -10459,7 +10534,7 @@
             </a:r>
           </a:p>
           <a:p>
-            <a:pPr algn="ctr">
+            <a:pPr>
               <a:spcBef>
                 <a:spcPts val="1000"/>
               </a:spcBef>
@@ -10474,11 +10549,11 @@
             </a:r>
           </a:p>
           <a:p>
-            <a:pPr algn="ctr">
+            <a:pPr>
               <a:spcBef>
                 <a:spcPts val="2000"/>
               </a:spcBef>
-              <a:defRPr sz="1400">
+              <a:defRPr sz="1300">
                 <a:solidFill>
                   <a:srgbClr val="48CAE4"/>
                 </a:solidFill>
@@ -10489,7 +10564,7 @@
             </a:r>
           </a:p>
           <a:p>
-            <a:pPr algn="ctr">
+            <a:pPr>
               <a:spcBef>
                 <a:spcPts val="1200"/>
               </a:spcBef>
@@ -10500,15 +10575,19 @@
               </a:defRPr>
             </a:pPr>
             <a:r>
-              <a:t>Team Members: BARATHKUMAR M &amp; SUBASH P  |  Dept of AI &amp; ML</a:t>
-            </a:r>
-          </a:p>
-          <a:p>
-            <a:pPr algn="ctr">
+              <a:t>Team Members: BARATHKUMAR M &amp; SUBASH P</a:t>
+            </a:r>
+            <a:br/>
+            <a:r>
+              <a:t>Dept of Artificial Intelligence &amp; Machine Learning</a:t>
+            </a:r>
+          </a:p>
+          <a:p>
+            <a:pPr>
               <a:spcBef>
                 <a:spcPts val="1600"/>
               </a:spcBef>
-              <a:defRPr sz="1300">
+              <a:defRPr sz="1200">
                 <a:solidFill>
                   <a:srgbClr val="8D99AE"/>
                 </a:solidFill>
@@ -10520,6 +10599,30 @@
           </a:p>
         </p:txBody>
       </p:sp>
+      <p:pic>
+        <p:nvPicPr>
+          <p:cNvPr id="5" name="Picture 4" descr="security_shield.jpg"/>
+          <p:cNvPicPr>
+            <a:picLocks noChangeAspect="1"/>
+          </p:cNvPicPr>
+          <p:nvPr/>
+        </p:nvPicPr>
+        <p:blipFill>
+          <a:blip r:embed="rId1"/>
+          <a:stretch>
+            <a:fillRect/>
+          </a:stretch>
+        </p:blipFill>
+        <p:spPr>
+          <a:xfrm>
+            <a:off x="7772400" y="1188720"/>
+            <a:ext cx="3383280" cy="4480560"/>
+          </a:xfrm>
+          <a:prstGeom prst="rect">
+            <a:avLst/>
+          </a:prstGeom>
+        </p:spPr>
+      </p:pic>
     </p:spTree>
   </p:cSld>
   <p:clrMapOvr>
@@ -10529,7 +10632,7 @@
 </file>
 
 <file path=ppt/slides/slide2.xml><?xml version="1.0" encoding="utf-8"?>
-<p:sld xmlns:a="http://schemas.openxmlformats.org/drawingml/2006/main" xmlns:p="http://schemas.openxmlformats.org/presentationml/2006/main" xmlns:r="http://schemas.openxmlformats.org/officeDocument/2006/relationships">
+<p:sld xmlns:a="http://schemas.openxmlformats.org/drawingml/2006/main" xmlns:r="http://schemas.openxmlformats.org/officeDocument/2006/relationships" xmlns:p="http://schemas.openxmlformats.org/presentationml/2006/main">
   <p:cSld>
     <p:spTree>
       <p:nvGrpSpPr>
@@ -10608,7 +10711,7 @@
                 <a:solidFill>
                   <a:srgbClr val="00F2FE"/>
                 </a:solidFill>
-                <a:latin typeface="Calibri"/>
+                <a:latin typeface="Calibri" panose="020F0502020204030204"/>
               </a:defRPr>
             </a:pPr>
             <a:r>
@@ -10644,7 +10747,7 @@
                 <a:solidFill>
                   <a:srgbClr val="FFFFFF"/>
                 </a:solidFill>
-                <a:latin typeface="Calibri"/>
+                <a:latin typeface="Calibri" panose="020F0502020204030204"/>
               </a:defRPr>
             </a:pPr>
             <a:r>
@@ -10680,7 +10783,7 @@
                 <a:solidFill>
                   <a:srgbClr val="8D99AE"/>
                 </a:solidFill>
-                <a:latin typeface="Calibri"/>
+                <a:latin typeface="Calibri" panose="020F0502020204030204"/>
               </a:defRPr>
             </a:pPr>
             <a:r>
@@ -11068,7 +11171,7 @@
 </file>
 
 <file path=ppt/slides/slide3.xml><?xml version="1.0" encoding="utf-8"?>
-<p:sld xmlns:a="http://schemas.openxmlformats.org/drawingml/2006/main" xmlns:p="http://schemas.openxmlformats.org/presentationml/2006/main" xmlns:r="http://schemas.openxmlformats.org/officeDocument/2006/relationships">
+<p:sld xmlns:a="http://schemas.openxmlformats.org/drawingml/2006/main" xmlns:r="http://schemas.openxmlformats.org/officeDocument/2006/relationships" xmlns:p="http://schemas.openxmlformats.org/presentationml/2006/main">
   <p:cSld>
     <p:spTree>
       <p:nvGrpSpPr>
@@ -11147,7 +11250,7 @@
                 <a:solidFill>
                   <a:srgbClr val="00F2FE"/>
                 </a:solidFill>
-                <a:latin typeface="Calibri"/>
+                <a:latin typeface="Calibri" panose="020F0502020204030204"/>
               </a:defRPr>
             </a:pPr>
             <a:r>
@@ -11183,7 +11286,7 @@
                 <a:solidFill>
                   <a:srgbClr val="FFFFFF"/>
                 </a:solidFill>
-                <a:latin typeface="Calibri"/>
+                <a:latin typeface="Calibri" panose="020F0502020204030204"/>
               </a:defRPr>
             </a:pPr>
             <a:r>
@@ -11219,7 +11322,7 @@
                 <a:solidFill>
                   <a:srgbClr val="8D99AE"/>
                 </a:solidFill>
-                <a:latin typeface="Calibri"/>
+                <a:latin typeface="Calibri" panose="020F0502020204030204"/>
               </a:defRPr>
             </a:pPr>
             <a:r>
@@ -11237,7 +11340,7 @@
         <p:spPr>
           <a:xfrm>
             <a:off x="731520" y="1463040"/>
-            <a:ext cx="10698480" cy="804672"/>
+            <a:ext cx="7132320" cy="804672"/>
           </a:xfrm>
           <a:prstGeom prst="roundRect">
             <a:avLst/>
@@ -11281,8 +11384,8 @@
         </p:nvSpPr>
         <p:spPr>
           <a:xfrm>
-            <a:off x="1005840" y="1536192"/>
-            <a:ext cx="10149840" cy="658368"/>
+            <a:off x="914400" y="1536192"/>
+            <a:ext cx="6766560" cy="658368"/>
           </a:xfrm>
           <a:prstGeom prst="rect">
             <a:avLst/>
@@ -11296,7 +11399,7 @@
           <a:lstStyle/>
           <a:p>
             <a:r>
-              <a:rPr b="1" sz="1500">
+              <a:rPr sz="1400" b="1">
                 <a:solidFill>
                   <a:srgbClr val="00F2FE"/>
                 </a:solidFill>
@@ -11304,13 +11407,18 @@
               <a:t>AI Security Gateway: </a:t>
             </a:r>
             <a:r>
-              <a:rPr sz="1400">
+              <a:rPr sz="1300">
                 <a:solidFill>
                   <a:srgbClr val="FFFFFF"/>
                 </a:solidFill>
               </a:rPr>
               <a:t>Acts as an inline security barrier placed between enterprise users and external LLM models.</a:t>
             </a:r>
+            <a:endParaRPr sz="1300">
+              <a:solidFill>
+                <a:srgbClr val="FFFFFF"/>
+              </a:solidFill>
+            </a:endParaRPr>
           </a:p>
         </p:txBody>
       </p:sp>
@@ -11323,7 +11431,7 @@
         <p:spPr>
           <a:xfrm>
             <a:off x="731520" y="2395728"/>
-            <a:ext cx="10698480" cy="804672"/>
+            <a:ext cx="7132320" cy="804672"/>
           </a:xfrm>
           <a:prstGeom prst="roundRect">
             <a:avLst/>
@@ -11367,8 +11475,8 @@
         </p:nvSpPr>
         <p:spPr>
           <a:xfrm>
-            <a:off x="1005840" y="2468880"/>
-            <a:ext cx="10149840" cy="658368"/>
+            <a:off x="914400" y="2468880"/>
+            <a:ext cx="6766560" cy="658368"/>
           </a:xfrm>
           <a:prstGeom prst="rect">
             <a:avLst/>
@@ -11382,7 +11490,7 @@
           <a:lstStyle/>
           <a:p>
             <a:r>
-              <a:rPr b="1" sz="1500">
+              <a:rPr sz="1400" b="1">
                 <a:solidFill>
                   <a:srgbClr val="00F2FE"/>
                 </a:solidFill>
@@ -11390,13 +11498,18 @@
               <a:t>Universal PII Masking: </a:t>
             </a:r>
             <a:r>
-              <a:rPr sz="1400">
+              <a:rPr sz="1300">
                 <a:solidFill>
                   <a:srgbClr val="FFFFFF"/>
                 </a:solidFill>
               </a:rPr>
-              <a:t>Scans prompts for 20 sensitive entity types (Aadhaar, PAN, Bank Accounts, Passwords) and applies partial masking.</a:t>
-            </a:r>
+              <a:t>Scans prompts for 20 sensitive entity types (Aadhaar, PAN, Bank Accounts) and applies partial masking.</a:t>
+            </a:r>
+            <a:endParaRPr sz="1300">
+              <a:solidFill>
+                <a:srgbClr val="FFFFFF"/>
+              </a:solidFill>
+            </a:endParaRPr>
           </a:p>
         </p:txBody>
       </p:sp>
@@ -11409,7 +11522,7 @@
         <p:spPr>
           <a:xfrm>
             <a:off x="731520" y="3328416"/>
-            <a:ext cx="10698480" cy="804672"/>
+            <a:ext cx="7132320" cy="804672"/>
           </a:xfrm>
           <a:prstGeom prst="roundRect">
             <a:avLst/>
@@ -11453,8 +11566,8 @@
         </p:nvSpPr>
         <p:spPr>
           <a:xfrm>
-            <a:off x="1005840" y="3401568"/>
-            <a:ext cx="10149840" cy="658368"/>
+            <a:off x="914400" y="3401568"/>
+            <a:ext cx="6766560" cy="658368"/>
           </a:xfrm>
           <a:prstGeom prst="rect">
             <a:avLst/>
@@ -11468,7 +11581,7 @@
           <a:lstStyle/>
           <a:p>
             <a:r>
-              <a:rPr b="1" sz="1500">
+              <a:rPr sz="1400" b="1">
                 <a:solidFill>
                   <a:srgbClr val="00F2FE"/>
                 </a:solidFill>
@@ -11476,13 +11589,18 @@
               <a:t>Prompt Injection Defense: </a:t>
             </a:r>
             <a:r>
-              <a:rPr sz="1400">
+              <a:rPr sz="1300">
                 <a:solidFill>
                   <a:srgbClr val="FFFFFF"/>
                 </a:solidFill>
               </a:rPr>
               <a:t>Detects and blocks jailbreak attacks (DAN prompts) before they reach foundation models.</a:t>
             </a:r>
+            <a:endParaRPr sz="1300">
+              <a:solidFill>
+                <a:srgbClr val="FFFFFF"/>
+              </a:solidFill>
+            </a:endParaRPr>
           </a:p>
         </p:txBody>
       </p:sp>
@@ -11495,7 +11613,7 @@
         <p:spPr>
           <a:xfrm>
             <a:off x="731520" y="4261104"/>
-            <a:ext cx="10698480" cy="804672"/>
+            <a:ext cx="7132320" cy="804672"/>
           </a:xfrm>
           <a:prstGeom prst="roundRect">
             <a:avLst/>
@@ -11539,8 +11657,8 @@
         </p:nvSpPr>
         <p:spPr>
           <a:xfrm>
-            <a:off x="1005840" y="4334256"/>
-            <a:ext cx="10149840" cy="658368"/>
+            <a:off x="914400" y="4334256"/>
+            <a:ext cx="6766560" cy="658368"/>
           </a:xfrm>
           <a:prstGeom prst="rect">
             <a:avLst/>
@@ -11554,7 +11672,7 @@
           <a:lstStyle/>
           <a:p>
             <a:r>
-              <a:rPr b="1" sz="1500">
+              <a:rPr sz="1400" b="1">
                 <a:solidFill>
                   <a:srgbClr val="00F2FE"/>
                 </a:solidFill>
@@ -11562,13 +11680,18 @@
               <a:t>Risk Scoring Engine: </a:t>
             </a:r>
             <a:r>
-              <a:rPr sz="1400">
+              <a:rPr sz="1300">
                 <a:solidFill>
                   <a:srgbClr val="FFFFFF"/>
                 </a:solidFill>
               </a:rPr>
               <a:t>Calculates real-time risk scores (0% to 100%) and displays explainable AI (XAI) security decision logs.</a:t>
             </a:r>
+            <a:endParaRPr sz="1300">
+              <a:solidFill>
+                <a:srgbClr val="FFFFFF"/>
+              </a:solidFill>
+            </a:endParaRPr>
           </a:p>
         </p:txBody>
       </p:sp>
@@ -11581,7 +11704,7 @@
         <p:spPr>
           <a:xfrm>
             <a:off x="731520" y="5193792"/>
-            <a:ext cx="10698480" cy="804672"/>
+            <a:ext cx="7132320" cy="804672"/>
           </a:xfrm>
           <a:prstGeom prst="roundRect">
             <a:avLst/>
@@ -11625,8 +11748,8 @@
         </p:nvSpPr>
         <p:spPr>
           <a:xfrm>
-            <a:off x="1005840" y="5266944"/>
-            <a:ext cx="10149840" cy="658368"/>
+            <a:off x="914400" y="5266944"/>
+            <a:ext cx="6766560" cy="658368"/>
           </a:xfrm>
           <a:prstGeom prst="rect">
             <a:avLst/>
@@ -11640,7 +11763,7 @@
           <a:lstStyle/>
           <a:p>
             <a:r>
-              <a:rPr b="1" sz="1500">
+              <a:rPr sz="1400" b="1">
                 <a:solidFill>
                   <a:srgbClr val="00F2FE"/>
                 </a:solidFill>
@@ -11648,16 +11771,45 @@
               <a:t>Cryptographic Audit Ledger: </a:t>
             </a:r>
             <a:r>
-              <a:rPr sz="1400">
+              <a:rPr sz="1300">
                 <a:solidFill>
                   <a:srgbClr val="FFFFFF"/>
                 </a:solidFill>
               </a:rPr>
-              <a:t>Stores security events in a tamper-proof SHA-256 blockchain audit trail for regulatory compliance.</a:t>
-            </a:r>
-          </a:p>
-        </p:txBody>
-      </p:sp>
+              <a:t>Stores security events in a tamper-proof SHA-256 blockchain audit trail for compliance.</a:t>
+            </a:r>
+            <a:endParaRPr sz="1300">
+              <a:solidFill>
+                <a:srgbClr val="FFFFFF"/>
+              </a:solidFill>
+            </a:endParaRPr>
+          </a:p>
+        </p:txBody>
+      </p:sp>
+      <p:pic>
+        <p:nvPicPr>
+          <p:cNvPr id="16" name="Picture 15" descr="security_shield.jpg"/>
+          <p:cNvPicPr>
+            <a:picLocks noChangeAspect="1"/>
+          </p:cNvPicPr>
+          <p:nvPr/>
+        </p:nvPicPr>
+        <p:blipFill>
+          <a:blip r:embed="rId1"/>
+          <a:stretch>
+            <a:fillRect/>
+          </a:stretch>
+        </p:blipFill>
+        <p:spPr>
+          <a:xfrm>
+            <a:off x="8138160" y="1463040"/>
+            <a:ext cx="3291840" cy="4572000"/>
+          </a:xfrm>
+          <a:prstGeom prst="rect">
+            <a:avLst/>
+          </a:prstGeom>
+        </p:spPr>
+      </p:pic>
     </p:spTree>
   </p:cSld>
   <p:clrMapOvr>
@@ -11667,7 +11819,7 @@
 </file>
 
 <file path=ppt/slides/slide4.xml><?xml version="1.0" encoding="utf-8"?>
-<p:sld xmlns:a="http://schemas.openxmlformats.org/drawingml/2006/main" xmlns:p="http://schemas.openxmlformats.org/presentationml/2006/main" xmlns:r="http://schemas.openxmlformats.org/officeDocument/2006/relationships">
+<p:sld xmlns:a="http://schemas.openxmlformats.org/drawingml/2006/main" xmlns:r="http://schemas.openxmlformats.org/officeDocument/2006/relationships" xmlns:p="http://schemas.openxmlformats.org/presentationml/2006/main">
   <p:cSld>
     <p:spTree>
       <p:nvGrpSpPr>
@@ -11746,7 +11898,7 @@
                 <a:solidFill>
                   <a:srgbClr val="00F2FE"/>
                 </a:solidFill>
-                <a:latin typeface="Calibri"/>
+                <a:latin typeface="Calibri" panose="020F0502020204030204"/>
               </a:defRPr>
             </a:pPr>
             <a:r>
@@ -11782,7 +11934,7 @@
                 <a:solidFill>
                   <a:srgbClr val="FFFFFF"/>
                 </a:solidFill>
-                <a:latin typeface="Calibri"/>
+                <a:latin typeface="Calibri" panose="020F0502020204030204"/>
               </a:defRPr>
             </a:pPr>
             <a:r>
@@ -11818,7 +11970,7 @@
                 <a:solidFill>
                   <a:srgbClr val="8D99AE"/>
                 </a:solidFill>
-                <a:latin typeface="Calibri"/>
+                <a:latin typeface="Calibri" panose="020F0502020204030204"/>
               </a:defRPr>
             </a:pPr>
             <a:r>
@@ -11895,7 +12047,7 @@
           <a:lstStyle/>
           <a:p>
             <a:r>
-              <a:rPr b="1" sz="1500">
+              <a:rPr sz="1500" b="1">
                 <a:solidFill>
                   <a:srgbClr val="FF0055"/>
                 </a:solidFill>
@@ -11910,6 +12062,11 @@
               </a:rPr>
               <a:t> Employees frequently paste secret source code, customer details, and identity numbers into AI tools.</a:t>
             </a:r>
+            <a:endParaRPr sz="1400">
+              <a:solidFill>
+                <a:srgbClr val="FFFFFF"/>
+              </a:solidFill>
+            </a:endParaRPr>
           </a:p>
         </p:txBody>
       </p:sp>
@@ -11981,7 +12138,7 @@
           <a:lstStyle/>
           <a:p>
             <a:r>
-              <a:rPr b="1" sz="1500">
+              <a:rPr sz="1500" b="1">
                 <a:solidFill>
                   <a:srgbClr val="FF0055"/>
                 </a:solidFill>
@@ -11996,6 +12153,11 @@
               </a:rPr>
               <a:t> Public LLM servers store prompt history, risking exposure of confidential citizen data.</a:t>
             </a:r>
+            <a:endParaRPr sz="1400">
+              <a:solidFill>
+                <a:srgbClr val="FFFFFF"/>
+              </a:solidFill>
+            </a:endParaRPr>
           </a:p>
         </p:txBody>
       </p:sp>
@@ -12067,7 +12229,7 @@
           <a:lstStyle/>
           <a:p>
             <a:r>
-              <a:rPr b="1" sz="1500">
+              <a:rPr sz="1500" b="1">
                 <a:solidFill>
                   <a:srgbClr val="FF0055"/>
                 </a:solidFill>
@@ -12082,6 +12244,11 @@
               </a:rPr>
               <a:t> Standard regex filters fail on Indian 12-digit Aadhaar cards, PAN numbers, and IFSC codes.</a:t>
             </a:r>
+            <a:endParaRPr sz="1400">
+              <a:solidFill>
+                <a:srgbClr val="FFFFFF"/>
+              </a:solidFill>
+            </a:endParaRPr>
           </a:p>
         </p:txBody>
       </p:sp>
@@ -12153,7 +12320,7 @@
           <a:lstStyle/>
           <a:p>
             <a:r>
-              <a:rPr b="1" sz="1500">
+              <a:rPr sz="1500" b="1">
                 <a:solidFill>
                   <a:srgbClr val="FF0055"/>
                 </a:solidFill>
@@ -12168,6 +12335,11 @@
               </a:rPr>
               <a:t> Hackers use prompt injection tricks (DAN payloads) to bypass safety guardrails.</a:t>
             </a:r>
+            <a:endParaRPr sz="1400">
+              <a:solidFill>
+                <a:srgbClr val="FFFFFF"/>
+              </a:solidFill>
+            </a:endParaRPr>
           </a:p>
         </p:txBody>
       </p:sp>
@@ -12239,7 +12411,7 @@
           <a:lstStyle/>
           <a:p>
             <a:r>
-              <a:rPr b="1" sz="1500">
+              <a:rPr sz="1500" b="1">
                 <a:solidFill>
                   <a:srgbClr val="FF0055"/>
                 </a:solidFill>
@@ -12254,6 +12426,11 @@
               </a:rPr>
               <a:t> Organizations have no centralized system to track AI usage, calculate risk, or prove regulatory compliance.</a:t>
             </a:r>
+            <a:endParaRPr sz="1400">
+              <a:solidFill>
+                <a:srgbClr val="FFFFFF"/>
+              </a:solidFill>
+            </a:endParaRPr>
           </a:p>
         </p:txBody>
       </p:sp>
@@ -12266,7 +12443,7 @@
 </file>
 
 <file path=ppt/slides/slide5.xml><?xml version="1.0" encoding="utf-8"?>
-<p:sld xmlns:a="http://schemas.openxmlformats.org/drawingml/2006/main" xmlns:p="http://schemas.openxmlformats.org/presentationml/2006/main" xmlns:r="http://schemas.openxmlformats.org/officeDocument/2006/relationships">
+<p:sld xmlns:a="http://schemas.openxmlformats.org/drawingml/2006/main" xmlns:r="http://schemas.openxmlformats.org/officeDocument/2006/relationships" xmlns:p="http://schemas.openxmlformats.org/presentationml/2006/main">
   <p:cSld>
     <p:spTree>
       <p:nvGrpSpPr>
@@ -12345,7 +12522,7 @@
                 <a:solidFill>
                   <a:srgbClr val="00F2FE"/>
                 </a:solidFill>
-                <a:latin typeface="Calibri"/>
+                <a:latin typeface="Calibri" panose="020F0502020204030204"/>
               </a:defRPr>
             </a:pPr>
             <a:r>
@@ -12381,7 +12558,7 @@
                 <a:solidFill>
                   <a:srgbClr val="FFFFFF"/>
                 </a:solidFill>
-                <a:latin typeface="Calibri"/>
+                <a:latin typeface="Calibri" panose="020F0502020204030204"/>
               </a:defRPr>
             </a:pPr>
             <a:r>
@@ -12417,7 +12594,7 @@
                 <a:solidFill>
                   <a:srgbClr val="8D99AE"/>
                 </a:solidFill>
-                <a:latin typeface="Calibri"/>
+                <a:latin typeface="Calibri" panose="020F0502020204030204"/>
               </a:defRPr>
             </a:pPr>
             <a:r>
@@ -12494,7 +12671,7 @@
           <a:lstStyle/>
           <a:p>
             <a:r>
-              <a:rPr b="1" sz="1500">
+              <a:rPr sz="1500" b="1">
                 <a:solidFill>
                   <a:srgbClr val="00F2FE"/>
                 </a:solidFill>
@@ -12509,6 +12686,11 @@
               </a:rPr>
               <a:t> Detect and sanitize 20 sensitive entity types in under 50 milliseconds.</a:t>
             </a:r>
+            <a:endParaRPr sz="1400">
+              <a:solidFill>
+                <a:srgbClr val="FFFFFF"/>
+              </a:solidFill>
+            </a:endParaRPr>
           </a:p>
         </p:txBody>
       </p:sp>
@@ -12580,7 +12762,7 @@
           <a:lstStyle/>
           <a:p>
             <a:r>
-              <a:rPr b="1" sz="1500">
+              <a:rPr sz="1500" b="1">
                 <a:solidFill>
                   <a:srgbClr val="00F2FE"/>
                 </a:solidFill>
@@ -12593,8 +12775,13 @@
                   <a:srgbClr val="FFFFFF"/>
                 </a:solidFill>
               </a:rPr>
-              <a:t> Hide critical digits (e.g. XXXX XXXX 9012) while keeping prompt meaning intact.</a:t>
-            </a:r>
+              <a:t> Hide critical digits (e.g., XXXX XXXX 9012) while keeping prompt meaning intact.</a:t>
+            </a:r>
+            <a:endParaRPr sz="1400">
+              <a:solidFill>
+                <a:srgbClr val="FFFFFF"/>
+              </a:solidFill>
+            </a:endParaRPr>
           </a:p>
         </p:txBody>
       </p:sp>
@@ -12666,7 +12853,7 @@
           <a:lstStyle/>
           <a:p>
             <a:r>
-              <a:rPr b="1" sz="1500">
+              <a:rPr sz="1500" b="1">
                 <a:solidFill>
                   <a:srgbClr val="00F2FE"/>
                 </a:solidFill>
@@ -12681,6 +12868,11 @@
               </a:rPr>
               <a:t> Block DAN jailbreaks, system overrides, and context poisoning attempts.</a:t>
             </a:r>
+            <a:endParaRPr sz="1400">
+              <a:solidFill>
+                <a:srgbClr val="FFFFFF"/>
+              </a:solidFill>
+            </a:endParaRPr>
           </a:p>
         </p:txBody>
       </p:sp>
@@ -12752,7 +12944,7 @@
           <a:lstStyle/>
           <a:p>
             <a:r>
-              <a:rPr b="1" sz="1500">
+              <a:rPr sz="1500" b="1">
                 <a:solidFill>
                   <a:srgbClr val="00F2FE"/>
                 </a:solidFill>
@@ -12767,6 +12959,11 @@
               </a:rPr>
               <a:t> Assign real-time threat scores (0% to 100%) with explainable decision logs.</a:t>
             </a:r>
+            <a:endParaRPr sz="1400">
+              <a:solidFill>
+                <a:srgbClr val="FFFFFF"/>
+              </a:solidFill>
+            </a:endParaRPr>
           </a:p>
         </p:txBody>
       </p:sp>
@@ -12838,7 +13035,7 @@
           <a:lstStyle/>
           <a:p>
             <a:r>
-              <a:rPr b="1" sz="1500">
+              <a:rPr sz="1500" b="1">
                 <a:solidFill>
                   <a:srgbClr val="00F2FE"/>
                 </a:solidFill>
@@ -12853,6 +13050,11 @@
               </a:rPr>
               <a:t> Store tamper-proof security logs using a cryptographic SHA-256 blockchain ledger.</a:t>
             </a:r>
+            <a:endParaRPr sz="1400">
+              <a:solidFill>
+                <a:srgbClr val="FFFFFF"/>
+              </a:solidFill>
+            </a:endParaRPr>
           </a:p>
         </p:txBody>
       </p:sp>
@@ -12865,7 +13067,7 @@
 </file>
 
 <file path=ppt/slides/slide6.xml><?xml version="1.0" encoding="utf-8"?>
-<p:sld xmlns:a="http://schemas.openxmlformats.org/drawingml/2006/main" xmlns:p="http://schemas.openxmlformats.org/presentationml/2006/main" xmlns:r="http://schemas.openxmlformats.org/officeDocument/2006/relationships">
+<p:sld xmlns:a="http://schemas.openxmlformats.org/drawingml/2006/main" xmlns:r="http://schemas.openxmlformats.org/officeDocument/2006/relationships" xmlns:p="http://schemas.openxmlformats.org/presentationml/2006/main">
   <p:cSld>
     <p:spTree>
       <p:nvGrpSpPr>
@@ -12944,7 +13146,7 @@
                 <a:solidFill>
                   <a:srgbClr val="00F2FE"/>
                 </a:solidFill>
-                <a:latin typeface="Calibri"/>
+                <a:latin typeface="Calibri" panose="020F0502020204030204"/>
               </a:defRPr>
             </a:pPr>
             <a:r>
@@ -12980,7 +13182,7 @@
                 <a:solidFill>
                   <a:srgbClr val="FFFFFF"/>
                 </a:solidFill>
-                <a:latin typeface="Calibri"/>
+                <a:latin typeface="Calibri" panose="020F0502020204030204"/>
               </a:defRPr>
             </a:pPr>
             <a:r>
@@ -13016,7 +13218,7 @@
                 <a:solidFill>
                   <a:srgbClr val="8D99AE"/>
                 </a:solidFill>
-                <a:latin typeface="Calibri"/>
+                <a:latin typeface="Calibri" panose="020F0502020204030204"/>
               </a:defRPr>
             </a:pPr>
             <a:r>
@@ -13344,7 +13546,7 @@
 </file>
 
 <file path=ppt/slides/slide7.xml><?xml version="1.0" encoding="utf-8"?>
-<p:sld xmlns:a="http://schemas.openxmlformats.org/drawingml/2006/main" xmlns:p="http://schemas.openxmlformats.org/presentationml/2006/main" xmlns:r="http://schemas.openxmlformats.org/officeDocument/2006/relationships">
+<p:sld xmlns:a="http://schemas.openxmlformats.org/drawingml/2006/main" xmlns:r="http://schemas.openxmlformats.org/officeDocument/2006/relationships" xmlns:p="http://schemas.openxmlformats.org/presentationml/2006/main">
   <p:cSld>
     <p:spTree>
       <p:nvGrpSpPr>
@@ -13423,7 +13625,7 @@
                 <a:solidFill>
                   <a:srgbClr val="00F2FE"/>
                 </a:solidFill>
-                <a:latin typeface="Calibri"/>
+                <a:latin typeface="Calibri" panose="020F0502020204030204"/>
               </a:defRPr>
             </a:pPr>
             <a:r>
@@ -13459,7 +13661,7 @@
                 <a:solidFill>
                   <a:srgbClr val="FFFFFF"/>
                 </a:solidFill>
-                <a:latin typeface="Calibri"/>
+                <a:latin typeface="Calibri" panose="020F0502020204030204"/>
               </a:defRPr>
             </a:pPr>
             <a:r>
@@ -13495,7 +13697,7 @@
                 <a:solidFill>
                   <a:srgbClr val="8D99AE"/>
                 </a:solidFill>
-                <a:latin typeface="Calibri"/>
+                <a:latin typeface="Calibri" panose="020F0502020204030204"/>
               </a:defRPr>
             </a:pPr>
             <a:r>
@@ -14173,7 +14375,7 @@
 </file>
 
 <file path=ppt/slides/slide8.xml><?xml version="1.0" encoding="utf-8"?>
-<p:sld xmlns:a="http://schemas.openxmlformats.org/drawingml/2006/main" xmlns:p="http://schemas.openxmlformats.org/presentationml/2006/main" xmlns:r="http://schemas.openxmlformats.org/officeDocument/2006/relationships">
+<p:sld xmlns:a="http://schemas.openxmlformats.org/drawingml/2006/main" xmlns:r="http://schemas.openxmlformats.org/officeDocument/2006/relationships" xmlns:p="http://schemas.openxmlformats.org/presentationml/2006/main">
   <p:cSld>
     <p:spTree>
       <p:nvGrpSpPr>
@@ -14252,7 +14454,7 @@
                 <a:solidFill>
                   <a:srgbClr val="00F2FE"/>
                 </a:solidFill>
-                <a:latin typeface="Calibri"/>
+                <a:latin typeface="Calibri" panose="020F0502020204030204"/>
               </a:defRPr>
             </a:pPr>
             <a:r>
@@ -14288,7 +14490,7 @@
                 <a:solidFill>
                   <a:srgbClr val="FFFFFF"/>
                 </a:solidFill>
-                <a:latin typeface="Calibri"/>
+                <a:latin typeface="Calibri" panose="020F0502020204030204"/>
               </a:defRPr>
             </a:pPr>
             <a:r>
@@ -14324,7 +14526,7 @@
                 <a:solidFill>
                   <a:srgbClr val="8D99AE"/>
                 </a:solidFill>
-                <a:latin typeface="Calibri"/>
+                <a:latin typeface="Calibri" panose="020F0502020204030204"/>
               </a:defRPr>
             </a:pPr>
             <a:r>
@@ -14341,8 +14543,8 @@
         </p:nvSpPr>
         <p:spPr>
           <a:xfrm>
-            <a:off x="731520" y="2011680"/>
-            <a:ext cx="1920240" cy="2377440"/>
+            <a:off x="731520" y="1463040"/>
+            <a:ext cx="1920240" cy="2011680"/>
           </a:xfrm>
           <a:prstGeom prst="roundRect">
             <a:avLst/>
@@ -14386,8 +14588,8 @@
         </p:nvSpPr>
         <p:spPr>
           <a:xfrm>
-            <a:off x="822960" y="2148840"/>
-            <a:ext cx="1737360" cy="2103120"/>
+            <a:off x="822960" y="1572768"/>
+            <a:ext cx="1737360" cy="1737360"/>
           </a:xfrm>
           <a:prstGeom prst="rect">
             <a:avLst/>
@@ -14401,7 +14603,7 @@
           <a:lstStyle/>
           <a:p>
             <a:pPr algn="ctr">
-              <a:defRPr sz="1400" b="1">
+              <a:defRPr sz="1300" b="1">
                 <a:solidFill>
                   <a:srgbClr val="00F2FE"/>
                 </a:solidFill>
@@ -14414,9 +14616,9 @@
           <a:p>
             <a:pPr algn="ctr">
               <a:spcBef>
-                <a:spcPts val="1000"/>
+                <a:spcPts val="800"/>
               </a:spcBef>
-              <a:defRPr sz="1100">
+              <a:defRPr sz="1050">
                 <a:solidFill>
                   <a:srgbClr val="FFFFFF"/>
                 </a:solidFill>
@@ -14436,8 +14638,8 @@
         </p:nvSpPr>
         <p:spPr>
           <a:xfrm>
-            <a:off x="2670048" y="3017520"/>
-            <a:ext cx="219456" cy="365760"/>
+            <a:off x="2670048" y="2286000"/>
+            <a:ext cx="219456" cy="320040"/>
           </a:xfrm>
           <a:prstGeom prst="rightArrow">
             <a:avLst/>
@@ -14479,8 +14681,8 @@
         </p:nvSpPr>
         <p:spPr>
           <a:xfrm>
-            <a:off x="2926080" y="2011680"/>
-            <a:ext cx="1920240" cy="2377440"/>
+            <a:off x="2926080" y="1463040"/>
+            <a:ext cx="1920240" cy="2011680"/>
           </a:xfrm>
           <a:prstGeom prst="roundRect">
             <a:avLst/>
@@ -14524,8 +14726,8 @@
         </p:nvSpPr>
         <p:spPr>
           <a:xfrm>
-            <a:off x="3017520" y="2148840"/>
-            <a:ext cx="1737360" cy="2103120"/>
+            <a:off x="3017520" y="1572768"/>
+            <a:ext cx="1737360" cy="1737360"/>
           </a:xfrm>
           <a:prstGeom prst="rect">
             <a:avLst/>
@@ -14539,7 +14741,7 @@
           <a:lstStyle/>
           <a:p>
             <a:pPr algn="ctr">
-              <a:defRPr sz="1400" b="1">
+              <a:defRPr sz="1300" b="1">
                 <a:solidFill>
                   <a:srgbClr val="00F2FE"/>
                 </a:solidFill>
@@ -14552,9 +14754,9 @@
           <a:p>
             <a:pPr algn="ctr">
               <a:spcBef>
-                <a:spcPts val="1000"/>
+                <a:spcPts val="800"/>
               </a:spcBef>
-              <a:defRPr sz="1100">
+              <a:defRPr sz="1050">
                 <a:solidFill>
                   <a:srgbClr val="FFFFFF"/>
                 </a:solidFill>
@@ -14574,8 +14776,8 @@
         </p:nvSpPr>
         <p:spPr>
           <a:xfrm>
-            <a:off x="4864608" y="3017520"/>
-            <a:ext cx="219456" cy="365760"/>
+            <a:off x="4864608" y="2286000"/>
+            <a:ext cx="219456" cy="320040"/>
           </a:xfrm>
           <a:prstGeom prst="rightArrow">
             <a:avLst/>
@@ -14617,8 +14819,8 @@
         </p:nvSpPr>
         <p:spPr>
           <a:xfrm>
-            <a:off x="5120640" y="2011680"/>
-            <a:ext cx="1920240" cy="2377440"/>
+            <a:off x="5120640" y="1463040"/>
+            <a:ext cx="1920240" cy="2011680"/>
           </a:xfrm>
           <a:prstGeom prst="roundRect">
             <a:avLst/>
@@ -14662,8 +14864,8 @@
         </p:nvSpPr>
         <p:spPr>
           <a:xfrm>
-            <a:off x="5212080" y="2148840"/>
-            <a:ext cx="1737360" cy="2103120"/>
+            <a:off x="5212080" y="1572768"/>
+            <a:ext cx="1737360" cy="1737360"/>
           </a:xfrm>
           <a:prstGeom prst="rect">
             <a:avLst/>
@@ -14677,7 +14879,7 @@
           <a:lstStyle/>
           <a:p>
             <a:pPr algn="ctr">
-              <a:defRPr sz="1400" b="1">
+              <a:defRPr sz="1300" b="1">
                 <a:solidFill>
                   <a:srgbClr val="00F2FE"/>
                 </a:solidFill>
@@ -14690,9 +14892,9 @@
           <a:p>
             <a:pPr algn="ctr">
               <a:spcBef>
-                <a:spcPts val="1000"/>
+                <a:spcPts val="800"/>
               </a:spcBef>
-              <a:defRPr sz="1100">
+              <a:defRPr sz="1050">
                 <a:solidFill>
                   <a:srgbClr val="FFFFFF"/>
                 </a:solidFill>
@@ -14712,8 +14914,8 @@
         </p:nvSpPr>
         <p:spPr>
           <a:xfrm>
-            <a:off x="7059168" y="3017520"/>
-            <a:ext cx="219456" cy="365760"/>
+            <a:off x="7059168" y="2286000"/>
+            <a:ext cx="219456" cy="320040"/>
           </a:xfrm>
           <a:prstGeom prst="rightArrow">
             <a:avLst/>
@@ -14755,8 +14957,8 @@
         </p:nvSpPr>
         <p:spPr>
           <a:xfrm>
-            <a:off x="7315199" y="2011680"/>
-            <a:ext cx="1920240" cy="2377440"/>
+            <a:off x="7315199" y="1463040"/>
+            <a:ext cx="1920240" cy="2011680"/>
           </a:xfrm>
           <a:prstGeom prst="roundRect">
             <a:avLst/>
@@ -14800,8 +15002,8 @@
         </p:nvSpPr>
         <p:spPr>
           <a:xfrm>
-            <a:off x="7406639" y="2148840"/>
-            <a:ext cx="1737360" cy="2103120"/>
+            <a:off x="7406639" y="1572768"/>
+            <a:ext cx="1737360" cy="1737360"/>
           </a:xfrm>
           <a:prstGeom prst="rect">
             <a:avLst/>
@@ -14815,7 +15017,7 @@
           <a:lstStyle/>
           <a:p>
             <a:pPr algn="ctr">
-              <a:defRPr sz="1400" b="1">
+              <a:defRPr sz="1300" b="1">
                 <a:solidFill>
                   <a:srgbClr val="00F2FE"/>
                 </a:solidFill>
@@ -14828,9 +15030,9 @@
           <a:p>
             <a:pPr algn="ctr">
               <a:spcBef>
-                <a:spcPts val="1000"/>
+                <a:spcPts val="800"/>
               </a:spcBef>
-              <a:defRPr sz="1100">
+              <a:defRPr sz="1050">
                 <a:solidFill>
                   <a:srgbClr val="FFFFFF"/>
                 </a:solidFill>
@@ -14850,8 +15052,8 @@
         </p:nvSpPr>
         <p:spPr>
           <a:xfrm>
-            <a:off x="9253727" y="3017520"/>
-            <a:ext cx="219456" cy="365760"/>
+            <a:off x="9253727" y="2286000"/>
+            <a:ext cx="219456" cy="320040"/>
           </a:xfrm>
           <a:prstGeom prst="rightArrow">
             <a:avLst/>
@@ -14893,8 +15095,8 @@
         </p:nvSpPr>
         <p:spPr>
           <a:xfrm>
-            <a:off x="9509760" y="2011680"/>
-            <a:ext cx="1920240" cy="2377440"/>
+            <a:off x="9509760" y="1463040"/>
+            <a:ext cx="1920240" cy="2011680"/>
           </a:xfrm>
           <a:prstGeom prst="roundRect">
             <a:avLst/>
@@ -14938,8 +15140,8 @@
         </p:nvSpPr>
         <p:spPr>
           <a:xfrm>
-            <a:off x="9601200" y="2148840"/>
-            <a:ext cx="1737360" cy="2103120"/>
+            <a:off x="9601200" y="1572768"/>
+            <a:ext cx="1737360" cy="1737360"/>
           </a:xfrm>
           <a:prstGeom prst="rect">
             <a:avLst/>
@@ -14953,7 +15155,7 @@
           <a:lstStyle/>
           <a:p>
             <a:pPr algn="ctr">
-              <a:defRPr sz="1400" b="1">
+              <a:defRPr sz="1300" b="1">
                 <a:solidFill>
                   <a:srgbClr val="00F2FE"/>
                 </a:solidFill>
@@ -14966,9 +15168,9 @@
           <a:p>
             <a:pPr algn="ctr">
               <a:spcBef>
-                <a:spcPts val="1000"/>
+                <a:spcPts val="800"/>
               </a:spcBef>
-              <a:defRPr sz="1100">
+              <a:defRPr sz="1050">
                 <a:solidFill>
                   <a:srgbClr val="FFFFFF"/>
                 </a:solidFill>
@@ -14980,105 +15182,30 @@
           </a:p>
         </p:txBody>
       </p:sp>
-      <p:sp>
-        <p:nvSpPr>
-          <p:cNvPr id="20" name="Rounded Rectangle 19"/>
-          <p:cNvSpPr/>
-          <p:nvPr/>
-        </p:nvSpPr>
-        <p:spPr>
-          <a:xfrm>
-            <a:off x="731520" y="4754880"/>
-            <a:ext cx="10698480" cy="1188720"/>
-          </a:xfrm>
-          <a:prstGeom prst="roundRect">
-            <a:avLst/>
-          </a:prstGeom>
-          <a:solidFill>
-            <a:srgbClr val="1C2541"/>
-          </a:solidFill>
-          <a:ln w="12700">
-            <a:solidFill>
-              <a:srgbClr val="48CAE4"/>
-            </a:solidFill>
-          </a:ln>
-        </p:spPr>
-        <p:style>
-          <a:lnRef idx="1">
-            <a:schemeClr val="accent1"/>
-          </a:lnRef>
-          <a:fillRef idx="3">
-            <a:schemeClr val="accent1"/>
-          </a:fillRef>
-          <a:effectRef idx="2">
-            <a:schemeClr val="accent1"/>
-          </a:effectRef>
-          <a:fontRef idx="minor">
-            <a:schemeClr val="lt1"/>
-          </a:fontRef>
-        </p:style>
-        <p:txBody>
-          <a:bodyPr rtlCol="0" anchor="ctr"/>
-          <a:lstStyle/>
-          <a:p>
-            <a:pPr algn="ctr"/>
-          </a:p>
-        </p:txBody>
-      </p:sp>
-      <p:sp>
-        <p:nvSpPr>
-          <p:cNvPr id="21" name="TextBox 20"/>
-          <p:cNvSpPr txBox="1"/>
-          <p:nvPr/>
-        </p:nvSpPr>
-        <p:spPr>
-          <a:xfrm>
-            <a:off x="914400" y="4846320"/>
-            <a:ext cx="10332720" cy="1005840"/>
+      <p:pic>
+        <p:nvPicPr>
+          <p:cNvPr id="20" name="Picture 19" descr="security_shield.jpg"/>
+          <p:cNvPicPr>
+            <a:picLocks noChangeAspect="1"/>
+          </p:cNvPicPr>
+          <p:nvPr/>
+        </p:nvPicPr>
+        <p:blipFill>
+          <a:blip r:embed="rId1"/>
+          <a:stretch>
+            <a:fillRect/>
+          </a:stretch>
+        </p:blipFill>
+        <p:spPr>
+          <a:xfrm>
+            <a:off x="731520" y="3749039"/>
+            <a:ext cx="10698480" cy="2377440"/>
           </a:xfrm>
           <a:prstGeom prst="rect">
             <a:avLst/>
           </a:prstGeom>
-          <a:noFill/>
-        </p:spPr>
-        <p:txBody>
-          <a:bodyPr wrap="square">
-            <a:spAutoFit/>
-          </a:bodyPr>
-          <a:lstStyle/>
-          <a:p>
-            <a:pPr>
-              <a:defRPr sz="1400" b="1">
-                <a:solidFill>
-                  <a:srgbClr val="00F2FE"/>
-                </a:solidFill>
-              </a:defRPr>
-            </a:pPr>
-            <a:r>
-              <a:t>Architecture Summary:</a:t>
-            </a:r>
-          </a:p>
-          <a:p>
-            <a:pPr>
-              <a:spcBef>
-                <a:spcPts val="400"/>
-              </a:spcBef>
-              <a:defRPr sz="1300">
-                <a:solidFill>
-                  <a:srgbClr val="FFFFFF"/>
-                </a:solidFill>
-              </a:defRPr>
-            </a:pPr>
-            <a:r>
-              <a:t>• The gateway intercepts raw user prompts in real time (&lt; 50ms processing latency).</a:t>
-            </a:r>
-            <a:br/>
-            <a:r>
-              <a:t>• If threats or PII are found, the text is sanitized and logged before reaching foundation LLM endpoints.</a:t>
-            </a:r>
-          </a:p>
-        </p:txBody>
-      </p:sp>
+        </p:spPr>
+      </p:pic>
     </p:spTree>
   </p:cSld>
   <p:clrMapOvr>
@@ -15088,7 +15215,7 @@
 </file>
 
 <file path=ppt/slides/slide9.xml><?xml version="1.0" encoding="utf-8"?>
-<p:sld xmlns:a="http://schemas.openxmlformats.org/drawingml/2006/main" xmlns:p="http://schemas.openxmlformats.org/presentationml/2006/main" xmlns:r="http://schemas.openxmlformats.org/officeDocument/2006/relationships">
+<p:sld xmlns:a="http://schemas.openxmlformats.org/drawingml/2006/main" xmlns:r="http://schemas.openxmlformats.org/officeDocument/2006/relationships" xmlns:p="http://schemas.openxmlformats.org/presentationml/2006/main">
   <p:cSld>
     <p:spTree>
       <p:nvGrpSpPr>
@@ -15167,7 +15294,7 @@
                 <a:solidFill>
                   <a:srgbClr val="00F2FE"/>
                 </a:solidFill>
-                <a:latin typeface="Calibri"/>
+                <a:latin typeface="Calibri" panose="020F0502020204030204"/>
               </a:defRPr>
             </a:pPr>
             <a:r>
@@ -15203,7 +15330,7 @@
                 <a:solidFill>
                   <a:srgbClr val="FFFFFF"/>
                 </a:solidFill>
-                <a:latin typeface="Calibri"/>
+                <a:latin typeface="Calibri" panose="020F0502020204030204"/>
               </a:defRPr>
             </a:pPr>
             <a:r>
@@ -15239,7 +15366,7 @@
                 <a:solidFill>
                   <a:srgbClr val="8D99AE"/>
                 </a:solidFill>
-                <a:latin typeface="Calibri"/>
+                <a:latin typeface="Calibri" panose="020F0502020204030204"/>
               </a:defRPr>
             </a:pPr>
             <a:r>
@@ -15316,7 +15443,7 @@
           <a:lstStyle/>
           <a:p>
             <a:r>
-              <a:rPr b="1" sz="1500">
+              <a:rPr sz="1500" b="1">
                 <a:solidFill>
                   <a:srgbClr val="00F2FE"/>
                 </a:solidFill>
@@ -15331,6 +15458,11 @@
               </a:rPr>
               <a:t>Scans text for 20 sensitive entity types including Indian Aadhaar, PAN, Bank Accounts, Passports, and API Keys.</a:t>
             </a:r>
+            <a:endParaRPr sz="1300">
+              <a:solidFill>
+                <a:srgbClr val="FFFFFF"/>
+              </a:solidFill>
+            </a:endParaRPr>
           </a:p>
         </p:txBody>
       </p:sp>
@@ -15402,7 +15534,7 @@
           <a:lstStyle/>
           <a:p>
             <a:r>
-              <a:rPr b="1" sz="1500">
+              <a:rPr sz="1500" b="1">
                 <a:solidFill>
                   <a:srgbClr val="00F2FE"/>
                 </a:solidFill>
@@ -15417,6 +15549,11 @@
               </a:rPr>
               <a:t>Detects Do-Anything-Now (DAN) jailbreaks, system prompt overrides, and context poisoning attempts.</a:t>
             </a:r>
+            <a:endParaRPr sz="1300">
+              <a:solidFill>
+                <a:srgbClr val="FFFFFF"/>
+              </a:solidFill>
+            </a:endParaRPr>
           </a:p>
         </p:txBody>
       </p:sp>
@@ -15488,7 +15625,7 @@
           <a:lstStyle/>
           <a:p>
             <a:r>
-              <a:rPr b="1" sz="1500">
+              <a:rPr sz="1500" b="1">
                 <a:solidFill>
                   <a:srgbClr val="00F2FE"/>
                 </a:solidFill>
@@ -15503,6 +15640,11 @@
               </a:rPr>
               <a:t>Allows administrators to switch preset profiles (Enterprise, Healthcare, Banking, Government) or toggle custom rules.</a:t>
             </a:r>
+            <a:endParaRPr sz="1300">
+              <a:solidFill>
+                <a:srgbClr val="FFFFFF"/>
+              </a:solidFill>
+            </a:endParaRPr>
           </a:p>
         </p:txBody>
       </p:sp>
@@ -15574,7 +15716,7 @@
           <a:lstStyle/>
           <a:p>
             <a:r>
-              <a:rPr b="1" sz="1500">
+              <a:rPr sz="1500" b="1">
                 <a:solidFill>
                   <a:srgbClr val="00F2FE"/>
                 </a:solidFill>
@@ -15589,6 +15731,11 @@
               </a:rPr>
               <a:t>Calculates live risk scores (0% to 100%) and displays explainable AI decision logs with highlighted diffs.</a:t>
             </a:r>
+            <a:endParaRPr sz="1300">
+              <a:solidFill>
+                <a:srgbClr val="FFFFFF"/>
+              </a:solidFill>
+            </a:endParaRPr>
           </a:p>
         </p:txBody>
       </p:sp>
@@ -15660,7 +15807,7 @@
           <a:lstStyle/>
           <a:p>
             <a:r>
-              <a:rPr b="1" sz="1500">
+              <a:rPr sz="1500" b="1">
                 <a:solidFill>
                   <a:srgbClr val="00F2FE"/>
                 </a:solidFill>
@@ -15675,6 +15822,11 @@
               </a:rPr>
               <a:t>Records security events in an immutable SHA-256 blockchain ledger and clones policies across LLM providers.</a:t>
             </a:r>
+            <a:endParaRPr sz="1300">
+              <a:solidFill>
+                <a:srgbClr val="FFFFFF"/>
+              </a:solidFill>
+            </a:endParaRPr>
           </a:p>
         </p:txBody>
       </p:sp>
@@ -16002,7 +16154,11 @@
       </a:style>
     </a:lnDef>
   </a:objectDefaults>
-  <a:extraClrSchemeLst/>
+  <a:extLst>
+    <a:ext uri="{05A4C25C-085E-4340-85A3-A5531E510DB2}">
+      <thm15:themeFamily xmlns:thm15="http://schemas.microsoft.com/office/thememl/2012/main" name="Office Theme" id="{62F939B6-93AF-4DB8-9C6B-D6C7DFDC589F}" vid="{4A3C46E8-61CC-4603-A589-7422A47A8E4A}"/>
+    </a:ext>
+  </a:extLst>
 </a:theme>
 </file>
 
@@ -16322,6 +16478,10 @@
       </a:style>
     </a:lnDef>
   </a:objectDefaults>
-  <a:extraClrSchemeLst/>
+  <a:extLst>
+    <a:ext uri="{05A4C25C-085E-4340-85A3-A5531E510DB2}">
+      <thm15:themeFamily xmlns:thm15="http://schemas.microsoft.com/office/thememl/2012/main" name="Office Theme" id="{62F939B6-93AF-4DB8-9C6B-D6C7DFDC589F}" vid="{4A3C46E8-61CC-4603-A589-7422A47A8E4A}"/>
+    </a:ext>
+  </a:extLst>
 </a:theme>
 </file>
</xml_diff>